<commit_message>
Add notes on 2026.03.12.
</commit_message>
<xml_diff>
--- a/slide/CA3060-4-Control.pptx
+++ b/slide/CA3060-4-Control.pptx
@@ -7,10 +7,10 @@
     <p:sldMasterId id="2147483686" r:id="rId3"/>
   </p:sldMasterIdLst>
   <p:notesMasterIdLst>
-    <p:notesMasterId r:id="rId21"/>
+    <p:notesMasterId r:id="rId18"/>
   </p:notesMasterIdLst>
   <p:handoutMasterIdLst>
-    <p:handoutMasterId r:id="rId22"/>
+    <p:handoutMasterId r:id="rId19"/>
   </p:handoutMasterIdLst>
   <p:sldIdLst>
     <p:sldId id="256" r:id="rId4"/>
@@ -25,11 +25,8 @@
     <p:sldId id="647" r:id="rId13"/>
     <p:sldId id="648" r:id="rId14"/>
     <p:sldId id="657" r:id="rId15"/>
-    <p:sldId id="649" r:id="rId16"/>
-    <p:sldId id="650" r:id="rId17"/>
-    <p:sldId id="651" r:id="rId18"/>
-    <p:sldId id="658" r:id="rId19"/>
-    <p:sldId id="333" r:id="rId20"/>
+    <p:sldId id="658" r:id="rId16"/>
+    <p:sldId id="333" r:id="rId17"/>
   </p:sldIdLst>
   <p:sldSz cx="12192000" cy="6858000"/>
   <p:notesSz cx="6858000" cy="9144000"/>
@@ -233,7 +230,7 @@
           <a:p>
             <a:fld id="{2F43A5A2-ABA0-4772-A51C-C5F6F247E980}" type="datetimeFigureOut">
               <a:rPr lang="en-US" smtClean="0"/>
-              <a:t>3/7/2026</a:t>
+              <a:t>3/11/2026</a:t>
             </a:fld>
             <a:endParaRPr lang="en-US"/>
           </a:p>
@@ -410,7 +407,7 @@
           <a:p>
             <a:fld id="{3C1F4A7B-8284-4E61-88F9-84C6CA6E31E8}" type="datetimeFigureOut">
               <a:rPr lang="zh-TW" altLang="en-US" smtClean="0"/>
-              <a:t>2026/3/7</a:t>
+              <a:t>2026/3/11</a:t>
             </a:fld>
             <a:endParaRPr lang="zh-TW" altLang="en-US"/>
           </a:p>
@@ -798,438 +795,6 @@
       </p:grpSpPr>
       <p:sp>
         <p:nvSpPr>
-          <p:cNvPr id="2" name="幻灯片图像占位符 1"/>
-          <p:cNvSpPr>
-            <a:spLocks noGrp="1" noRot="1" noChangeAspect="1"/>
-          </p:cNvSpPr>
-          <p:nvPr>
-            <p:ph type="sldImg"/>
-          </p:nvPr>
-        </p:nvSpPr>
-        <p:spPr/>
-      </p:sp>
-      <p:sp>
-        <p:nvSpPr>
-          <p:cNvPr id="3" name="备注占位符 2"/>
-          <p:cNvSpPr>
-            <a:spLocks noGrp="1"/>
-          </p:cNvSpPr>
-          <p:nvPr>
-            <p:ph type="body" idx="1"/>
-          </p:nvPr>
-        </p:nvSpPr>
-        <p:spPr/>
-        <p:txBody>
-          <a:bodyPr/>
-          <a:lstStyle/>
-          <a:p>
-            <a:endParaRPr lang="zh-CN" altLang="en-US" dirty="0"/>
-          </a:p>
-        </p:txBody>
-      </p:sp>
-      <p:sp>
-        <p:nvSpPr>
-          <p:cNvPr id="4" name="灯片编号占位符 3"/>
-          <p:cNvSpPr>
-            <a:spLocks noGrp="1"/>
-          </p:cNvSpPr>
-          <p:nvPr>
-            <p:ph type="sldNum" sz="quarter" idx="5"/>
-          </p:nvPr>
-        </p:nvSpPr>
-        <p:spPr/>
-        <p:txBody>
-          <a:bodyPr/>
-          <a:lstStyle/>
-          <a:p>
-            <a:pPr marL="0" marR="0" lvl="0" indent="0" algn="r" defTabSz="914400" rtl="0" eaLnBrk="1" fontAlgn="auto" latinLnBrk="0" hangingPunct="1">
-              <a:lnSpc>
-                <a:spcPct val="100000"/>
-              </a:lnSpc>
-              <a:spcBef>
-                <a:spcPts val="0"/>
-              </a:spcBef>
-              <a:spcAft>
-                <a:spcPts val="0"/>
-              </a:spcAft>
-              <a:buClrTx/>
-              <a:buSzTx/>
-              <a:buFontTx/>
-              <a:buNone/>
-              <a:tabLst/>
-              <a:defRPr/>
-            </a:pPr>
-            <a:fld id="{286C40E4-B9C8-417B-AB00-3BF7F8038A2D}" type="slidenum">
-              <a:rPr kumimoji="0" lang="zh-TW" altLang="en-US" sz="1200" b="0" i="0" u="none" strike="noStrike" kern="1200" cap="none" spc="0" normalizeH="0" baseline="0" noProof="0" smtClean="0">
-                <a:ln>
-                  <a:noFill/>
-                </a:ln>
-                <a:solidFill>
-                  <a:prstClr val="black"/>
-                </a:solidFill>
-                <a:effectLst/>
-                <a:uLnTx/>
-                <a:uFillTx/>
-                <a:latin typeface="Calibri"/>
-                <a:ea typeface="新細明體" panose="02020500000000000000" pitchFamily="18" charset="-120"/>
-                <a:cs typeface="+mn-cs"/>
-              </a:rPr>
-              <a:pPr marL="0" marR="0" lvl="0" indent="0" algn="r" defTabSz="914400" rtl="0" eaLnBrk="1" fontAlgn="auto" latinLnBrk="0" hangingPunct="1">
-                <a:lnSpc>
-                  <a:spcPct val="100000"/>
-                </a:lnSpc>
-                <a:spcBef>
-                  <a:spcPts val="0"/>
-                </a:spcBef>
-                <a:spcAft>
-                  <a:spcPts val="0"/>
-                </a:spcAft>
-                <a:buClrTx/>
-                <a:buSzTx/>
-                <a:buFontTx/>
-                <a:buNone/>
-                <a:tabLst/>
-                <a:defRPr/>
-              </a:pPr>
-              <a:t>13</a:t>
-            </a:fld>
-            <a:endParaRPr kumimoji="0" lang="zh-TW" altLang="en-US" sz="1200" b="0" i="0" u="none" strike="noStrike" kern="1200" cap="none" spc="0" normalizeH="0" baseline="0" noProof="0">
-              <a:ln>
-                <a:noFill/>
-              </a:ln>
-              <a:solidFill>
-                <a:prstClr val="black"/>
-              </a:solidFill>
-              <a:effectLst/>
-              <a:uLnTx/>
-              <a:uFillTx/>
-              <a:latin typeface="Calibri"/>
-              <a:ea typeface="新細明體" panose="02020500000000000000" pitchFamily="18" charset="-120"/>
-              <a:cs typeface="+mn-cs"/>
-            </a:endParaRPr>
-          </a:p>
-        </p:txBody>
-      </p:sp>
-    </p:spTree>
-    <p:extLst>
-      <p:ext uri="{BB962C8B-B14F-4D97-AF65-F5344CB8AC3E}">
-        <p14:creationId xmlns:p14="http://schemas.microsoft.com/office/powerpoint/2010/main" val="1231329542"/>
-      </p:ext>
-    </p:extLst>
-  </p:cSld>
-  <p:clrMapOvr>
-    <a:masterClrMapping/>
-  </p:clrMapOvr>
-</p:notes>
-</file>
-
-<file path=ppt/notesSlides/notesSlide11.xml><?xml version="1.0" encoding="utf-8"?>
-<p:notes xmlns:a="http://schemas.openxmlformats.org/drawingml/2006/main" xmlns:r="http://schemas.openxmlformats.org/officeDocument/2006/relationships" xmlns:p="http://schemas.openxmlformats.org/presentationml/2006/main">
-  <p:cSld>
-    <p:spTree>
-      <p:nvGrpSpPr>
-        <p:cNvPr id="1" name=""/>
-        <p:cNvGrpSpPr/>
-        <p:nvPr/>
-      </p:nvGrpSpPr>
-      <p:grpSpPr>
-        <a:xfrm>
-          <a:off x="0" y="0"/>
-          <a:ext cx="0" cy="0"/>
-          <a:chOff x="0" y="0"/>
-          <a:chExt cx="0" cy="0"/>
-        </a:xfrm>
-      </p:grpSpPr>
-      <p:sp>
-        <p:nvSpPr>
-          <p:cNvPr id="2" name="幻灯片图像占位符 1"/>
-          <p:cNvSpPr>
-            <a:spLocks noGrp="1" noRot="1" noChangeAspect="1"/>
-          </p:cNvSpPr>
-          <p:nvPr>
-            <p:ph type="sldImg"/>
-          </p:nvPr>
-        </p:nvSpPr>
-        <p:spPr/>
-      </p:sp>
-      <p:sp>
-        <p:nvSpPr>
-          <p:cNvPr id="3" name="备注占位符 2"/>
-          <p:cNvSpPr>
-            <a:spLocks noGrp="1"/>
-          </p:cNvSpPr>
-          <p:nvPr>
-            <p:ph type="body" idx="1"/>
-          </p:nvPr>
-        </p:nvSpPr>
-        <p:spPr/>
-        <p:txBody>
-          <a:bodyPr/>
-          <a:lstStyle/>
-          <a:p>
-            <a:endParaRPr lang="zh-CN" altLang="en-US" dirty="0"/>
-          </a:p>
-        </p:txBody>
-      </p:sp>
-      <p:sp>
-        <p:nvSpPr>
-          <p:cNvPr id="4" name="灯片编号占位符 3"/>
-          <p:cNvSpPr>
-            <a:spLocks noGrp="1"/>
-          </p:cNvSpPr>
-          <p:nvPr>
-            <p:ph type="sldNum" sz="quarter" idx="5"/>
-          </p:nvPr>
-        </p:nvSpPr>
-        <p:spPr/>
-        <p:txBody>
-          <a:bodyPr/>
-          <a:lstStyle/>
-          <a:p>
-            <a:pPr marL="0" marR="0" lvl="0" indent="0" algn="r" defTabSz="914400" rtl="0" eaLnBrk="1" fontAlgn="auto" latinLnBrk="0" hangingPunct="1">
-              <a:lnSpc>
-                <a:spcPct val="100000"/>
-              </a:lnSpc>
-              <a:spcBef>
-                <a:spcPts val="0"/>
-              </a:spcBef>
-              <a:spcAft>
-                <a:spcPts val="0"/>
-              </a:spcAft>
-              <a:buClrTx/>
-              <a:buSzTx/>
-              <a:buFontTx/>
-              <a:buNone/>
-              <a:tabLst/>
-              <a:defRPr/>
-            </a:pPr>
-            <a:fld id="{286C40E4-B9C8-417B-AB00-3BF7F8038A2D}" type="slidenum">
-              <a:rPr kumimoji="0" lang="zh-TW" altLang="en-US" sz="1200" b="0" i="0" u="none" strike="noStrike" kern="1200" cap="none" spc="0" normalizeH="0" baseline="0" noProof="0" smtClean="0">
-                <a:ln>
-                  <a:noFill/>
-                </a:ln>
-                <a:solidFill>
-                  <a:prstClr val="black"/>
-                </a:solidFill>
-                <a:effectLst/>
-                <a:uLnTx/>
-                <a:uFillTx/>
-                <a:latin typeface="Calibri"/>
-                <a:ea typeface="新細明體" panose="02020500000000000000" pitchFamily="18" charset="-120"/>
-                <a:cs typeface="+mn-cs"/>
-              </a:rPr>
-              <a:pPr marL="0" marR="0" lvl="0" indent="0" algn="r" defTabSz="914400" rtl="0" eaLnBrk="1" fontAlgn="auto" latinLnBrk="0" hangingPunct="1">
-                <a:lnSpc>
-                  <a:spcPct val="100000"/>
-                </a:lnSpc>
-                <a:spcBef>
-                  <a:spcPts val="0"/>
-                </a:spcBef>
-                <a:spcAft>
-                  <a:spcPts val="0"/>
-                </a:spcAft>
-                <a:buClrTx/>
-                <a:buSzTx/>
-                <a:buFontTx/>
-                <a:buNone/>
-                <a:tabLst/>
-                <a:defRPr/>
-              </a:pPr>
-              <a:t>14</a:t>
-            </a:fld>
-            <a:endParaRPr kumimoji="0" lang="zh-TW" altLang="en-US" sz="1200" b="0" i="0" u="none" strike="noStrike" kern="1200" cap="none" spc="0" normalizeH="0" baseline="0" noProof="0">
-              <a:ln>
-                <a:noFill/>
-              </a:ln>
-              <a:solidFill>
-                <a:prstClr val="black"/>
-              </a:solidFill>
-              <a:effectLst/>
-              <a:uLnTx/>
-              <a:uFillTx/>
-              <a:latin typeface="Calibri"/>
-              <a:ea typeface="新細明體" panose="02020500000000000000" pitchFamily="18" charset="-120"/>
-              <a:cs typeface="+mn-cs"/>
-            </a:endParaRPr>
-          </a:p>
-        </p:txBody>
-      </p:sp>
-    </p:spTree>
-    <p:extLst>
-      <p:ext uri="{BB962C8B-B14F-4D97-AF65-F5344CB8AC3E}">
-        <p14:creationId xmlns:p14="http://schemas.microsoft.com/office/powerpoint/2010/main" val="3061005099"/>
-      </p:ext>
-    </p:extLst>
-  </p:cSld>
-  <p:clrMapOvr>
-    <a:masterClrMapping/>
-  </p:clrMapOvr>
-</p:notes>
-</file>
-
-<file path=ppt/notesSlides/notesSlide12.xml><?xml version="1.0" encoding="utf-8"?>
-<p:notes xmlns:a="http://schemas.openxmlformats.org/drawingml/2006/main" xmlns:r="http://schemas.openxmlformats.org/officeDocument/2006/relationships" xmlns:p="http://schemas.openxmlformats.org/presentationml/2006/main">
-  <p:cSld>
-    <p:spTree>
-      <p:nvGrpSpPr>
-        <p:cNvPr id="1" name=""/>
-        <p:cNvGrpSpPr/>
-        <p:nvPr/>
-      </p:nvGrpSpPr>
-      <p:grpSpPr>
-        <a:xfrm>
-          <a:off x="0" y="0"/>
-          <a:ext cx="0" cy="0"/>
-          <a:chOff x="0" y="0"/>
-          <a:chExt cx="0" cy="0"/>
-        </a:xfrm>
-      </p:grpSpPr>
-      <p:sp>
-        <p:nvSpPr>
-          <p:cNvPr id="2" name="幻灯片图像占位符 1"/>
-          <p:cNvSpPr>
-            <a:spLocks noGrp="1" noRot="1" noChangeAspect="1"/>
-          </p:cNvSpPr>
-          <p:nvPr>
-            <p:ph type="sldImg"/>
-          </p:nvPr>
-        </p:nvSpPr>
-        <p:spPr/>
-      </p:sp>
-      <p:sp>
-        <p:nvSpPr>
-          <p:cNvPr id="3" name="备注占位符 2"/>
-          <p:cNvSpPr>
-            <a:spLocks noGrp="1"/>
-          </p:cNvSpPr>
-          <p:nvPr>
-            <p:ph type="body" idx="1"/>
-          </p:nvPr>
-        </p:nvSpPr>
-        <p:spPr/>
-        <p:txBody>
-          <a:bodyPr/>
-          <a:lstStyle/>
-          <a:p>
-            <a:endParaRPr lang="zh-CN" altLang="en-US" dirty="0"/>
-          </a:p>
-        </p:txBody>
-      </p:sp>
-      <p:sp>
-        <p:nvSpPr>
-          <p:cNvPr id="4" name="灯片编号占位符 3"/>
-          <p:cNvSpPr>
-            <a:spLocks noGrp="1"/>
-          </p:cNvSpPr>
-          <p:nvPr>
-            <p:ph type="sldNum" sz="quarter" idx="5"/>
-          </p:nvPr>
-        </p:nvSpPr>
-        <p:spPr/>
-        <p:txBody>
-          <a:bodyPr/>
-          <a:lstStyle/>
-          <a:p>
-            <a:pPr marL="0" marR="0" lvl="0" indent="0" algn="r" defTabSz="914400" rtl="0" eaLnBrk="1" fontAlgn="auto" latinLnBrk="0" hangingPunct="1">
-              <a:lnSpc>
-                <a:spcPct val="100000"/>
-              </a:lnSpc>
-              <a:spcBef>
-                <a:spcPts val="0"/>
-              </a:spcBef>
-              <a:spcAft>
-                <a:spcPts val="0"/>
-              </a:spcAft>
-              <a:buClrTx/>
-              <a:buSzTx/>
-              <a:buFontTx/>
-              <a:buNone/>
-              <a:tabLst/>
-              <a:defRPr/>
-            </a:pPr>
-            <a:fld id="{286C40E4-B9C8-417B-AB00-3BF7F8038A2D}" type="slidenum">
-              <a:rPr kumimoji="0" lang="zh-TW" altLang="en-US" sz="1200" b="0" i="0" u="none" strike="noStrike" kern="1200" cap="none" spc="0" normalizeH="0" baseline="0" noProof="0" smtClean="0">
-                <a:ln>
-                  <a:noFill/>
-                </a:ln>
-                <a:solidFill>
-                  <a:prstClr val="black"/>
-                </a:solidFill>
-                <a:effectLst/>
-                <a:uLnTx/>
-                <a:uFillTx/>
-                <a:latin typeface="Calibri"/>
-                <a:ea typeface="新細明體" panose="02020500000000000000" pitchFamily="18" charset="-120"/>
-                <a:cs typeface="+mn-cs"/>
-              </a:rPr>
-              <a:pPr marL="0" marR="0" lvl="0" indent="0" algn="r" defTabSz="914400" rtl="0" eaLnBrk="1" fontAlgn="auto" latinLnBrk="0" hangingPunct="1">
-                <a:lnSpc>
-                  <a:spcPct val="100000"/>
-                </a:lnSpc>
-                <a:spcBef>
-                  <a:spcPts val="0"/>
-                </a:spcBef>
-                <a:spcAft>
-                  <a:spcPts val="0"/>
-                </a:spcAft>
-                <a:buClrTx/>
-                <a:buSzTx/>
-                <a:buFontTx/>
-                <a:buNone/>
-                <a:tabLst/>
-                <a:defRPr/>
-              </a:pPr>
-              <a:t>15</a:t>
-            </a:fld>
-            <a:endParaRPr kumimoji="0" lang="zh-TW" altLang="en-US" sz="1200" b="0" i="0" u="none" strike="noStrike" kern="1200" cap="none" spc="0" normalizeH="0" baseline="0" noProof="0">
-              <a:ln>
-                <a:noFill/>
-              </a:ln>
-              <a:solidFill>
-                <a:prstClr val="black"/>
-              </a:solidFill>
-              <a:effectLst/>
-              <a:uLnTx/>
-              <a:uFillTx/>
-              <a:latin typeface="Calibri"/>
-              <a:ea typeface="新細明體" panose="02020500000000000000" pitchFamily="18" charset="-120"/>
-              <a:cs typeface="+mn-cs"/>
-            </a:endParaRPr>
-          </a:p>
-        </p:txBody>
-      </p:sp>
-    </p:spTree>
-    <p:extLst>
-      <p:ext uri="{BB962C8B-B14F-4D97-AF65-F5344CB8AC3E}">
-        <p14:creationId xmlns:p14="http://schemas.microsoft.com/office/powerpoint/2010/main" val="1661952756"/>
-      </p:ext>
-    </p:extLst>
-  </p:cSld>
-  <p:clrMapOvr>
-    <a:masterClrMapping/>
-  </p:clrMapOvr>
-</p:notes>
-</file>
-
-<file path=ppt/notesSlides/notesSlide13.xml><?xml version="1.0" encoding="utf-8"?>
-<p:notes xmlns:a="http://schemas.openxmlformats.org/drawingml/2006/main" xmlns:r="http://schemas.openxmlformats.org/officeDocument/2006/relationships" xmlns:p="http://schemas.openxmlformats.org/presentationml/2006/main">
-  <p:cSld>
-    <p:spTree>
-      <p:nvGrpSpPr>
-        <p:cNvPr id="1" name=""/>
-        <p:cNvGrpSpPr/>
-        <p:nvPr/>
-      </p:nvGrpSpPr>
-      <p:grpSpPr>
-        <a:xfrm>
-          <a:off x="0" y="0"/>
-          <a:ext cx="0" cy="0"/>
-          <a:chOff x="0" y="0"/>
-          <a:chExt cx="0" cy="0"/>
-        </a:xfrm>
-      </p:grpSpPr>
-      <p:sp>
-        <p:nvSpPr>
           <p:cNvPr id="128002" name="Rectangle 2"/>
           <p:cNvSpPr>
             <a:spLocks noGrp="1" noChangeArrowheads="1"/>
@@ -1360,7 +925,7 @@
 </p:notes>
 </file>
 
-<file path=ppt/notesSlides/notesSlide14.xml><?xml version="1.0" encoding="utf-8"?>
+<file path=ppt/notesSlides/notesSlide11.xml><?xml version="1.0" encoding="utf-8"?>
 <p:notes xmlns:a="http://schemas.openxmlformats.org/drawingml/2006/main" xmlns:r="http://schemas.openxmlformats.org/officeDocument/2006/relationships" xmlns:p="http://schemas.openxmlformats.org/presentationml/2006/main">
   <p:cSld>
     <p:spTree>
@@ -12744,1106 +12309,6 @@
       </p:grpSpPr>
       <p:sp>
         <p:nvSpPr>
-          <p:cNvPr id="5" name="标题 4"/>
-          <p:cNvSpPr>
-            <a:spLocks noGrp="1"/>
-          </p:cNvSpPr>
-          <p:nvPr>
-            <p:ph type="title"/>
-          </p:nvPr>
-        </p:nvSpPr>
-        <p:spPr/>
-        <p:txBody>
-          <a:bodyPr/>
-          <a:lstStyle/>
-          <a:p>
-            <a:r>
-              <a:rPr lang="en-US" altLang="zh-CN" sz="4000" dirty="0"/>
-              <a:t>RV32I Control Logic Truth Table</a:t>
-            </a:r>
-          </a:p>
-        </p:txBody>
-      </p:sp>
-      <p:sp>
-        <p:nvSpPr>
-          <p:cNvPr id="4" name="灯片编号占位符 3"/>
-          <p:cNvSpPr>
-            <a:spLocks noGrp="1"/>
-          </p:cNvSpPr>
-          <p:nvPr>
-            <p:ph type="sldNum" sz="quarter" idx="10"/>
-          </p:nvPr>
-        </p:nvSpPr>
-        <p:spPr/>
-        <p:txBody>
-          <a:bodyPr/>
-          <a:lstStyle/>
-          <a:p>
-            <a:pPr defTabSz="1219170"/>
-            <a:fld id="{D9B6BDF2-6896-4B98-8776-C18582F63BA5}" type="slidenum">
-              <a:rPr lang="zh-TW" altLang="en-US">
-                <a:solidFill>
-                  <a:prstClr val="white"/>
-                </a:solidFill>
-              </a:rPr>
-              <a:pPr defTabSz="1219170"/>
-              <a:t>13</a:t>
-            </a:fld>
-            <a:endParaRPr lang="zh-TW" altLang="en-US">
-              <a:solidFill>
-                <a:prstClr val="white"/>
-              </a:solidFill>
-            </a:endParaRPr>
-          </a:p>
-        </p:txBody>
-      </p:sp>
-      <p:pic>
-        <p:nvPicPr>
-          <p:cNvPr id="3" name="Picture 2">
-            <a:extLst>
-              <a:ext uri="{FF2B5EF4-FFF2-40B4-BE49-F238E27FC236}">
-                <a16:creationId xmlns:a16="http://schemas.microsoft.com/office/drawing/2014/main" id="{ADFB0777-3EB9-42B3-9DAC-EC6680530C6C}"/>
-              </a:ext>
-            </a:extLst>
-          </p:cNvPr>
-          <p:cNvPicPr>
-            <a:picLocks noChangeAspect="1"/>
-          </p:cNvPicPr>
-          <p:nvPr/>
-        </p:nvPicPr>
-        <p:blipFill>
-          <a:blip r:embed="rId3"/>
-          <a:stretch>
-            <a:fillRect/>
-          </a:stretch>
-        </p:blipFill>
-        <p:spPr>
-          <a:xfrm>
-            <a:off x="970835" y="1011677"/>
-            <a:ext cx="10250330" cy="5389538"/>
-          </a:xfrm>
-          <a:prstGeom prst="rect">
-            <a:avLst/>
-          </a:prstGeom>
-        </p:spPr>
-      </p:pic>
-      <p:sp>
-        <p:nvSpPr>
-          <p:cNvPr id="2" name="Oval 1">
-            <a:extLst>
-              <a:ext uri="{FF2B5EF4-FFF2-40B4-BE49-F238E27FC236}">
-                <a16:creationId xmlns:a16="http://schemas.microsoft.com/office/drawing/2014/main" id="{09FFD8A4-5268-448C-8966-8425E4079008}"/>
-              </a:ext>
-            </a:extLst>
-          </p:cNvPr>
-          <p:cNvSpPr/>
-          <p:nvPr/>
-        </p:nvSpPr>
-        <p:spPr bwMode="auto">
-          <a:xfrm>
-            <a:off x="2334638" y="3234690"/>
-            <a:ext cx="3326860" cy="1543050"/>
-          </a:xfrm>
-          <a:prstGeom prst="ellipse">
-            <a:avLst/>
-          </a:prstGeom>
-          <a:noFill/>
-          <a:ln w="28575" cap="flat" cmpd="sng" algn="ctr">
-            <a:solidFill>
-              <a:srgbClr val="FF0000"/>
-            </a:solidFill>
-            <a:prstDash val="solid"/>
-            <a:round/>
-            <a:headEnd type="none" w="med" len="med"/>
-            <a:tailEnd type="none" w="med" len="med"/>
-          </a:ln>
-          <a:effectLst/>
-        </p:spPr>
-        <p:txBody>
-          <a:bodyPr vert="horz" wrap="none" lIns="91440" tIns="45720" rIns="91440" bIns="45720" numCol="1" rtlCol="0" anchor="ctr" anchorCtr="0" compatLnSpc="1">
-            <a:prstTxWarp prst="textNoShape">
-              <a:avLst/>
-            </a:prstTxWarp>
-          </a:bodyPr>
-          <a:lstStyle/>
-          <a:p>
-            <a:pPr marL="0" marR="0" indent="0" algn="ctr" defTabSz="914400" rtl="0" eaLnBrk="1" fontAlgn="base" latinLnBrk="0" hangingPunct="1">
-              <a:lnSpc>
-                <a:spcPct val="100000"/>
-              </a:lnSpc>
-              <a:spcBef>
-                <a:spcPct val="0"/>
-              </a:spcBef>
-              <a:spcAft>
-                <a:spcPct val="0"/>
-              </a:spcAft>
-              <a:buClrTx/>
-              <a:buSzTx/>
-              <a:buFontTx/>
-              <a:buNone/>
-              <a:tabLst/>
-            </a:pPr>
-            <a:endParaRPr kumimoji="1" lang="en-US" sz="1800" b="1" i="0" u="none" strike="noStrike" cap="none" normalizeH="0" baseline="0">
-              <a:ln>
-                <a:noFill/>
-              </a:ln>
-              <a:solidFill>
-                <a:schemeClr val="tx1"/>
-              </a:solidFill>
-              <a:effectLst/>
-              <a:latin typeface="Arial" pitchFamily="34" charset="0"/>
-              <a:ea typeface="新細明體" pitchFamily="18" charset="-120"/>
-            </a:endParaRPr>
-          </a:p>
-        </p:txBody>
-      </p:sp>
-      <p:sp>
-        <p:nvSpPr>
-          <p:cNvPr id="6" name="TextBox 5">
-            <a:extLst>
-              <a:ext uri="{FF2B5EF4-FFF2-40B4-BE49-F238E27FC236}">
-                <a16:creationId xmlns:a16="http://schemas.microsoft.com/office/drawing/2014/main" id="{BD9733AF-74A8-4E02-B2E7-2DCF02AD090E}"/>
-              </a:ext>
-            </a:extLst>
-          </p:cNvPr>
-          <p:cNvSpPr txBox="1"/>
-          <p:nvPr/>
-        </p:nvSpPr>
-        <p:spPr>
-          <a:xfrm>
-            <a:off x="2918297" y="6488668"/>
-            <a:ext cx="2961067" cy="369332"/>
-          </a:xfrm>
-          <a:prstGeom prst="rect">
-            <a:avLst/>
-          </a:prstGeom>
-          <a:solidFill>
-            <a:srgbClr val="FFFF00"/>
-          </a:solidFill>
-        </p:spPr>
-        <p:txBody>
-          <a:bodyPr wrap="none" rtlCol="0" anchor="ctr" anchorCtr="1">
-            <a:spAutoFit/>
-          </a:bodyPr>
-          <a:lstStyle/>
-          <a:p>
-            <a:r>
-              <a:rPr lang="en-US" dirty="0">
-                <a:ea typeface="標楷體" pitchFamily="65" charset="-120"/>
-                <a:cs typeface="Calibri" pitchFamily="34" charset="0"/>
-              </a:rPr>
-              <a:t>PC = PC+4 or </a:t>
-            </a:r>
-            <a:r>
-              <a:rPr lang="en-US" dirty="0" err="1">
-                <a:ea typeface="標楷體" pitchFamily="65" charset="-120"/>
-                <a:cs typeface="Calibri" pitchFamily="34" charset="0"/>
-              </a:rPr>
-              <a:t>PC+immed</a:t>
-            </a:r>
-            <a:r>
-              <a:rPr lang="en-US" dirty="0">
-                <a:ea typeface="標楷體" pitchFamily="65" charset="-120"/>
-                <a:cs typeface="Calibri" pitchFamily="34" charset="0"/>
-              </a:rPr>
-              <a:t>?</a:t>
-            </a:r>
-          </a:p>
-        </p:txBody>
-      </p:sp>
-      <p:cxnSp>
-        <p:nvCxnSpPr>
-          <p:cNvPr id="8" name="Straight Arrow Connector 7">
-            <a:extLst>
-              <a:ext uri="{FF2B5EF4-FFF2-40B4-BE49-F238E27FC236}">
-                <a16:creationId xmlns:a16="http://schemas.microsoft.com/office/drawing/2014/main" id="{ADB339BB-AEBA-4772-B2AC-11A7B27A4955}"/>
-              </a:ext>
-            </a:extLst>
-          </p:cNvPr>
-          <p:cNvCxnSpPr>
-            <a:cxnSpLocks/>
-          </p:cNvCxnSpPr>
-          <p:nvPr/>
-        </p:nvCxnSpPr>
-        <p:spPr bwMode="auto">
-          <a:xfrm flipV="1">
-            <a:off x="3900791" y="6128426"/>
-            <a:ext cx="0" cy="544908"/>
-          </a:xfrm>
-          <a:prstGeom prst="straightConnector1">
-            <a:avLst/>
-          </a:prstGeom>
-          <a:noFill/>
-          <a:ln w="57150" cap="flat" cmpd="sng" algn="ctr">
-            <a:solidFill>
-              <a:srgbClr val="FF0000"/>
-            </a:solidFill>
-            <a:prstDash val="solid"/>
-            <a:round/>
-            <a:headEnd type="none" w="med" len="med"/>
-            <a:tailEnd type="triangle"/>
-          </a:ln>
-          <a:effectLst/>
-        </p:spPr>
-      </p:cxnSp>
-      <p:sp>
-        <p:nvSpPr>
-          <p:cNvPr id="11" name="TextBox 10">
-            <a:extLst>
-              <a:ext uri="{FF2B5EF4-FFF2-40B4-BE49-F238E27FC236}">
-                <a16:creationId xmlns:a16="http://schemas.microsoft.com/office/drawing/2014/main" id="{2F25F239-E76C-4FF0-90AB-E62E510DECA5}"/>
-              </a:ext>
-            </a:extLst>
-          </p:cNvPr>
-          <p:cNvSpPr txBox="1"/>
-          <p:nvPr/>
-        </p:nvSpPr>
-        <p:spPr>
-          <a:xfrm>
-            <a:off x="9024203" y="6476309"/>
-            <a:ext cx="3012428" cy="369332"/>
-          </a:xfrm>
-          <a:prstGeom prst="rect">
-            <a:avLst/>
-          </a:prstGeom>
-          <a:solidFill>
-            <a:srgbClr val="FFFF00"/>
-          </a:solidFill>
-        </p:spPr>
-        <p:txBody>
-          <a:bodyPr wrap="none" rtlCol="0" anchor="ctr" anchorCtr="1">
-            <a:spAutoFit/>
-          </a:bodyPr>
-          <a:lstStyle/>
-          <a:p>
-            <a:r>
-              <a:rPr lang="en-US" dirty="0" err="1">
-                <a:ea typeface="標楷體" pitchFamily="65" charset="-120"/>
-                <a:cs typeface="Calibri" pitchFamily="34" charset="0"/>
-              </a:rPr>
-              <a:t>Wbsel</a:t>
-            </a:r>
-            <a:r>
-              <a:rPr lang="en-US" dirty="0">
-                <a:ea typeface="標楷體" pitchFamily="65" charset="-120"/>
-                <a:cs typeface="Calibri" pitchFamily="34" charset="0"/>
-              </a:rPr>
-              <a:t>: ALU, Mem, or PC+4</a:t>
-            </a:r>
-          </a:p>
-        </p:txBody>
-      </p:sp>
-      <p:cxnSp>
-        <p:nvCxnSpPr>
-          <p:cNvPr id="12" name="Straight Arrow Connector 11">
-            <a:extLst>
-              <a:ext uri="{FF2B5EF4-FFF2-40B4-BE49-F238E27FC236}">
-                <a16:creationId xmlns:a16="http://schemas.microsoft.com/office/drawing/2014/main" id="{E9D9C229-A87D-42AE-B0F1-64471BDDCFFB}"/>
-              </a:ext>
-            </a:extLst>
-          </p:cNvPr>
-          <p:cNvCxnSpPr>
-            <a:cxnSpLocks/>
-          </p:cNvCxnSpPr>
-          <p:nvPr/>
-        </p:nvCxnSpPr>
-        <p:spPr bwMode="auto">
-          <a:xfrm flipV="1">
-            <a:off x="10415081" y="6280906"/>
-            <a:ext cx="0" cy="544908"/>
-          </a:xfrm>
-          <a:prstGeom prst="straightConnector1">
-            <a:avLst/>
-          </a:prstGeom>
-          <a:noFill/>
-          <a:ln w="57150" cap="flat" cmpd="sng" algn="ctr">
-            <a:solidFill>
-              <a:srgbClr val="FF0000"/>
-            </a:solidFill>
-            <a:prstDash val="solid"/>
-            <a:round/>
-            <a:headEnd type="none" w="med" len="med"/>
-            <a:tailEnd type="triangle"/>
-          </a:ln>
-          <a:effectLst/>
-        </p:spPr>
-      </p:cxnSp>
-    </p:spTree>
-    <p:extLst>
-      <p:ext uri="{BB962C8B-B14F-4D97-AF65-F5344CB8AC3E}">
-        <p14:creationId xmlns:p14="http://schemas.microsoft.com/office/powerpoint/2010/main" val="2934470990"/>
-      </p:ext>
-    </p:extLst>
-  </p:cSld>
-  <p:clrMapOvr>
-    <a:masterClrMapping/>
-  </p:clrMapOvr>
-  <p:timing>
-    <p:tnLst>
-      <p:par>
-        <p:cTn id="1" dur="indefinite" restart="never" nodeType="tmRoot">
-          <p:childTnLst>
-            <p:seq concurrent="1" nextAc="seek">
-              <p:cTn id="2" dur="indefinite" nodeType="mainSeq">
-                <p:childTnLst>
-                  <p:par>
-                    <p:cTn id="3" fill="hold">
-                      <p:stCondLst>
-                        <p:cond delay="indefinite"/>
-                      </p:stCondLst>
-                      <p:childTnLst>
-                        <p:par>
-                          <p:cTn id="4" fill="hold">
-                            <p:stCondLst>
-                              <p:cond delay="0"/>
-                            </p:stCondLst>
-                            <p:childTnLst>
-                              <p:par>
-                                <p:cTn id="5" presetID="1" presetClass="entr" presetSubtype="0" fill="hold" grpId="0" nodeType="clickEffect">
-                                  <p:stCondLst>
-                                    <p:cond delay="0"/>
-                                  </p:stCondLst>
-                                  <p:childTnLst>
-                                    <p:set>
-                                      <p:cBhvr>
-                                        <p:cTn id="6" dur="1" fill="hold">
-                                          <p:stCondLst>
-                                            <p:cond delay="0"/>
-                                          </p:stCondLst>
-                                        </p:cTn>
-                                        <p:tgtEl>
-                                          <p:spTgt spid="2"/>
-                                        </p:tgtEl>
-                                        <p:attrNameLst>
-                                          <p:attrName>style.visibility</p:attrName>
-                                        </p:attrNameLst>
-                                      </p:cBhvr>
-                                      <p:to>
-                                        <p:strVal val="visible"/>
-                                      </p:to>
-                                    </p:set>
-                                  </p:childTnLst>
-                                </p:cTn>
-                              </p:par>
-                            </p:childTnLst>
-                          </p:cTn>
-                        </p:par>
-                      </p:childTnLst>
-                    </p:cTn>
-                  </p:par>
-                  <p:par>
-                    <p:cTn id="7" fill="hold">
-                      <p:stCondLst>
-                        <p:cond delay="indefinite"/>
-                      </p:stCondLst>
-                      <p:childTnLst>
-                        <p:par>
-                          <p:cTn id="8" fill="hold">
-                            <p:stCondLst>
-                              <p:cond delay="0"/>
-                            </p:stCondLst>
-                            <p:childTnLst>
-                              <p:par>
-                                <p:cTn id="9" presetID="1" presetClass="entr" presetSubtype="0" fill="hold" grpId="0" nodeType="clickEffect">
-                                  <p:stCondLst>
-                                    <p:cond delay="0"/>
-                                  </p:stCondLst>
-                                  <p:childTnLst>
-                                    <p:set>
-                                      <p:cBhvr>
-                                        <p:cTn id="10" dur="1" fill="hold">
-                                          <p:stCondLst>
-                                            <p:cond delay="0"/>
-                                          </p:stCondLst>
-                                        </p:cTn>
-                                        <p:tgtEl>
-                                          <p:spTgt spid="6"/>
-                                        </p:tgtEl>
-                                        <p:attrNameLst>
-                                          <p:attrName>style.visibility</p:attrName>
-                                        </p:attrNameLst>
-                                      </p:cBhvr>
-                                      <p:to>
-                                        <p:strVal val="visible"/>
-                                      </p:to>
-                                    </p:set>
-                                  </p:childTnLst>
-                                </p:cTn>
-                              </p:par>
-                            </p:childTnLst>
-                          </p:cTn>
-                        </p:par>
-                      </p:childTnLst>
-                    </p:cTn>
-                  </p:par>
-                  <p:par>
-                    <p:cTn id="11" fill="hold">
-                      <p:stCondLst>
-                        <p:cond delay="indefinite"/>
-                      </p:stCondLst>
-                      <p:childTnLst>
-                        <p:par>
-                          <p:cTn id="12" fill="hold">
-                            <p:stCondLst>
-                              <p:cond delay="0"/>
-                            </p:stCondLst>
-                            <p:childTnLst>
-                              <p:par>
-                                <p:cTn id="13" presetID="1" presetClass="entr" presetSubtype="0" fill="hold" nodeType="clickEffect">
-                                  <p:stCondLst>
-                                    <p:cond delay="0"/>
-                                  </p:stCondLst>
-                                  <p:childTnLst>
-                                    <p:set>
-                                      <p:cBhvr>
-                                        <p:cTn id="14" dur="1" fill="hold">
-                                          <p:stCondLst>
-                                            <p:cond delay="0"/>
-                                          </p:stCondLst>
-                                        </p:cTn>
-                                        <p:tgtEl>
-                                          <p:spTgt spid="8"/>
-                                        </p:tgtEl>
-                                        <p:attrNameLst>
-                                          <p:attrName>style.visibility</p:attrName>
-                                        </p:attrNameLst>
-                                      </p:cBhvr>
-                                      <p:to>
-                                        <p:strVal val="visible"/>
-                                      </p:to>
-                                    </p:set>
-                                  </p:childTnLst>
-                                </p:cTn>
-                              </p:par>
-                            </p:childTnLst>
-                          </p:cTn>
-                        </p:par>
-                      </p:childTnLst>
-                    </p:cTn>
-                  </p:par>
-                  <p:par>
-                    <p:cTn id="15" fill="hold">
-                      <p:stCondLst>
-                        <p:cond delay="indefinite"/>
-                      </p:stCondLst>
-                      <p:childTnLst>
-                        <p:par>
-                          <p:cTn id="16" fill="hold">
-                            <p:stCondLst>
-                              <p:cond delay="0"/>
-                            </p:stCondLst>
-                            <p:childTnLst>
-                              <p:par>
-                                <p:cTn id="17" presetID="1" presetClass="entr" presetSubtype="0" fill="hold" grpId="0" nodeType="clickEffect">
-                                  <p:stCondLst>
-                                    <p:cond delay="0"/>
-                                  </p:stCondLst>
-                                  <p:childTnLst>
-                                    <p:set>
-                                      <p:cBhvr>
-                                        <p:cTn id="18" dur="1" fill="hold">
-                                          <p:stCondLst>
-                                            <p:cond delay="0"/>
-                                          </p:stCondLst>
-                                        </p:cTn>
-                                        <p:tgtEl>
-                                          <p:spTgt spid="11"/>
-                                        </p:tgtEl>
-                                        <p:attrNameLst>
-                                          <p:attrName>style.visibility</p:attrName>
-                                        </p:attrNameLst>
-                                      </p:cBhvr>
-                                      <p:to>
-                                        <p:strVal val="visible"/>
-                                      </p:to>
-                                    </p:set>
-                                  </p:childTnLst>
-                                </p:cTn>
-                              </p:par>
-                            </p:childTnLst>
-                          </p:cTn>
-                        </p:par>
-                      </p:childTnLst>
-                    </p:cTn>
-                  </p:par>
-                  <p:par>
-                    <p:cTn id="19" fill="hold">
-                      <p:stCondLst>
-                        <p:cond delay="indefinite"/>
-                      </p:stCondLst>
-                      <p:childTnLst>
-                        <p:par>
-                          <p:cTn id="20" fill="hold">
-                            <p:stCondLst>
-                              <p:cond delay="0"/>
-                            </p:stCondLst>
-                            <p:childTnLst>
-                              <p:par>
-                                <p:cTn id="21" presetID="1" presetClass="entr" presetSubtype="0" fill="hold" nodeType="clickEffect">
-                                  <p:stCondLst>
-                                    <p:cond delay="0"/>
-                                  </p:stCondLst>
-                                  <p:childTnLst>
-                                    <p:set>
-                                      <p:cBhvr>
-                                        <p:cTn id="22" dur="1" fill="hold">
-                                          <p:stCondLst>
-                                            <p:cond delay="0"/>
-                                          </p:stCondLst>
-                                        </p:cTn>
-                                        <p:tgtEl>
-                                          <p:spTgt spid="12"/>
-                                        </p:tgtEl>
-                                        <p:attrNameLst>
-                                          <p:attrName>style.visibility</p:attrName>
-                                        </p:attrNameLst>
-                                      </p:cBhvr>
-                                      <p:to>
-                                        <p:strVal val="visible"/>
-                                      </p:to>
-                                    </p:set>
-                                  </p:childTnLst>
-                                </p:cTn>
-                              </p:par>
-                            </p:childTnLst>
-                          </p:cTn>
-                        </p:par>
-                      </p:childTnLst>
-                    </p:cTn>
-                  </p:par>
-                </p:childTnLst>
-              </p:cTn>
-              <p:prevCondLst>
-                <p:cond evt="onPrev" delay="0">
-                  <p:tgtEl>
-                    <p:sldTgt/>
-                  </p:tgtEl>
-                </p:cond>
-              </p:prevCondLst>
-              <p:nextCondLst>
-                <p:cond evt="onNext" delay="0">
-                  <p:tgtEl>
-                    <p:sldTgt/>
-                  </p:tgtEl>
-                </p:cond>
-              </p:nextCondLst>
-            </p:seq>
-          </p:childTnLst>
-        </p:cTn>
-      </p:par>
-    </p:tnLst>
-    <p:bldLst>
-      <p:bldP spid="2" grpId="0" animBg="1"/>
-      <p:bldP spid="6" grpId="0" animBg="1"/>
-      <p:bldP spid="11" grpId="0" animBg="1"/>
-    </p:bldLst>
-  </p:timing>
-</p:sld>
-</file>
-
-<file path=ppt/slides/slide14.xml><?xml version="1.0" encoding="utf-8"?>
-<p:sld xmlns:a="http://schemas.openxmlformats.org/drawingml/2006/main" xmlns:r="http://schemas.openxmlformats.org/officeDocument/2006/relationships" xmlns:p="http://schemas.openxmlformats.org/presentationml/2006/main">
-  <p:cSld>
-    <p:spTree>
-      <p:nvGrpSpPr>
-        <p:cNvPr id="1" name=""/>
-        <p:cNvGrpSpPr/>
-        <p:nvPr/>
-      </p:nvGrpSpPr>
-      <p:grpSpPr>
-        <a:xfrm>
-          <a:off x="0" y="0"/>
-          <a:ext cx="0" cy="0"/>
-          <a:chOff x="0" y="0"/>
-          <a:chExt cx="0" cy="0"/>
-        </a:xfrm>
-      </p:grpSpPr>
-      <p:sp>
-        <p:nvSpPr>
-          <p:cNvPr id="5" name="标题 4"/>
-          <p:cNvSpPr>
-            <a:spLocks noGrp="1"/>
-          </p:cNvSpPr>
-          <p:nvPr>
-            <p:ph type="title"/>
-          </p:nvPr>
-        </p:nvSpPr>
-        <p:spPr/>
-        <p:txBody>
-          <a:bodyPr/>
-          <a:lstStyle/>
-          <a:p>
-            <a:r>
-              <a:rPr lang="en-US" altLang="zh-CN" sz="4000" dirty="0"/>
-              <a:t>RV32I: 9 bits in Instruction drive the control</a:t>
-            </a:r>
-          </a:p>
-        </p:txBody>
-      </p:sp>
-      <p:sp>
-        <p:nvSpPr>
-          <p:cNvPr id="4" name="灯片编号占位符 3"/>
-          <p:cNvSpPr>
-            <a:spLocks noGrp="1"/>
-          </p:cNvSpPr>
-          <p:nvPr>
-            <p:ph type="sldNum" sz="quarter" idx="10"/>
-          </p:nvPr>
-        </p:nvSpPr>
-        <p:spPr/>
-        <p:txBody>
-          <a:bodyPr/>
-          <a:lstStyle/>
-          <a:p>
-            <a:pPr defTabSz="1219170"/>
-            <a:fld id="{D9B6BDF2-6896-4B98-8776-C18582F63BA5}" type="slidenum">
-              <a:rPr lang="zh-TW" altLang="en-US">
-                <a:solidFill>
-                  <a:prstClr val="white"/>
-                </a:solidFill>
-              </a:rPr>
-              <a:pPr defTabSz="1219170"/>
-              <a:t>14</a:t>
-            </a:fld>
-            <a:endParaRPr lang="zh-TW" altLang="en-US">
-              <a:solidFill>
-                <a:prstClr val="white"/>
-              </a:solidFill>
-            </a:endParaRPr>
-          </a:p>
-        </p:txBody>
-      </p:sp>
-      <p:pic>
-        <p:nvPicPr>
-          <p:cNvPr id="6" name="Picture 5">
-            <a:extLst>
-              <a:ext uri="{FF2B5EF4-FFF2-40B4-BE49-F238E27FC236}">
-                <a16:creationId xmlns:a16="http://schemas.microsoft.com/office/drawing/2014/main" id="{10224E80-F59C-410C-BE06-E506E778F20F}"/>
-              </a:ext>
-            </a:extLst>
-          </p:cNvPr>
-          <p:cNvPicPr>
-            <a:picLocks noChangeAspect="1"/>
-          </p:cNvPicPr>
-          <p:nvPr/>
-        </p:nvPicPr>
-        <p:blipFill>
-          <a:blip r:embed="rId3"/>
-          <a:stretch>
-            <a:fillRect/>
-          </a:stretch>
-        </p:blipFill>
-        <p:spPr>
-          <a:xfrm>
-            <a:off x="1049867" y="691292"/>
-            <a:ext cx="9259592" cy="6173061"/>
-          </a:xfrm>
-          <a:prstGeom prst="rect">
-            <a:avLst/>
-          </a:prstGeom>
-        </p:spPr>
-      </p:pic>
-      <p:sp>
-        <p:nvSpPr>
-          <p:cNvPr id="7" name="TextBox 6">
-            <a:extLst>
-              <a:ext uri="{FF2B5EF4-FFF2-40B4-BE49-F238E27FC236}">
-                <a16:creationId xmlns:a16="http://schemas.microsoft.com/office/drawing/2014/main" id="{A3661E4D-5B41-42E9-81D5-9514D6B93E26}"/>
-              </a:ext>
-            </a:extLst>
-          </p:cNvPr>
-          <p:cNvSpPr txBox="1"/>
-          <p:nvPr/>
-        </p:nvSpPr>
-        <p:spPr>
-          <a:xfrm>
-            <a:off x="7237379" y="6166708"/>
-            <a:ext cx="2813591" cy="369332"/>
-          </a:xfrm>
-          <a:prstGeom prst="rect">
-            <a:avLst/>
-          </a:prstGeom>
-          <a:noFill/>
-        </p:spPr>
-        <p:txBody>
-          <a:bodyPr wrap="none" rtlCol="0" anchor="ctr" anchorCtr="1">
-            <a:spAutoFit/>
-          </a:bodyPr>
-          <a:lstStyle/>
-          <a:p>
-            <a:r>
-              <a:rPr lang="en-US" dirty="0">
-                <a:solidFill>
-                  <a:srgbClr val="FFFF00"/>
-                </a:solidFill>
-                <a:ea typeface="標楷體" pitchFamily="65" charset="-120"/>
-                <a:cs typeface="Calibri" pitchFamily="34" charset="0"/>
-              </a:rPr>
-              <a:t>Add/Sub, Logic/</a:t>
-            </a:r>
-            <a:r>
-              <a:rPr lang="en-US" dirty="0" err="1">
-                <a:solidFill>
-                  <a:srgbClr val="FFFF00"/>
-                </a:solidFill>
-                <a:ea typeface="標楷體" pitchFamily="65" charset="-120"/>
-                <a:cs typeface="Calibri" pitchFamily="34" charset="0"/>
-              </a:rPr>
-              <a:t>Arith</a:t>
-            </a:r>
-            <a:r>
-              <a:rPr lang="en-US" dirty="0">
-                <a:solidFill>
-                  <a:srgbClr val="FFFF00"/>
-                </a:solidFill>
-                <a:ea typeface="標楷體" pitchFamily="65" charset="-120"/>
-                <a:cs typeface="Calibri" pitchFamily="34" charset="0"/>
-              </a:rPr>
-              <a:t> Shift</a:t>
-            </a:r>
-          </a:p>
-        </p:txBody>
-      </p:sp>
-      <p:sp>
-        <p:nvSpPr>
-          <p:cNvPr id="8" name="TextBox 7">
-            <a:extLst>
-              <a:ext uri="{FF2B5EF4-FFF2-40B4-BE49-F238E27FC236}">
-                <a16:creationId xmlns:a16="http://schemas.microsoft.com/office/drawing/2014/main" id="{370131CB-CA91-4AD4-BDE3-2812D21063C1}"/>
-              </a:ext>
-            </a:extLst>
-          </p:cNvPr>
-          <p:cNvSpPr txBox="1"/>
-          <p:nvPr/>
-        </p:nvSpPr>
-        <p:spPr>
-          <a:xfrm>
-            <a:off x="7496783" y="5389796"/>
-            <a:ext cx="813043" cy="369332"/>
-          </a:xfrm>
-          <a:prstGeom prst="rect">
-            <a:avLst/>
-          </a:prstGeom>
-          <a:noFill/>
-        </p:spPr>
-        <p:txBody>
-          <a:bodyPr wrap="none" rtlCol="0" anchor="ctr" anchorCtr="1">
-            <a:spAutoFit/>
-          </a:bodyPr>
-          <a:lstStyle/>
-          <a:p>
-            <a:r>
-              <a:rPr lang="en-US" dirty="0">
-                <a:solidFill>
-                  <a:srgbClr val="FFFF00"/>
-                </a:solidFill>
-                <a:ea typeface="標楷體" pitchFamily="65" charset="-120"/>
-                <a:cs typeface="Calibri" pitchFamily="34" charset="0"/>
-              </a:rPr>
-              <a:t>funct3</a:t>
-            </a:r>
-          </a:p>
-        </p:txBody>
-      </p:sp>
-      <p:sp>
-        <p:nvSpPr>
-          <p:cNvPr id="9" name="TextBox 8">
-            <a:extLst>
-              <a:ext uri="{FF2B5EF4-FFF2-40B4-BE49-F238E27FC236}">
-                <a16:creationId xmlns:a16="http://schemas.microsoft.com/office/drawing/2014/main" id="{8B375297-5890-4B86-8AC5-E4D5DC6B1846}"/>
-              </a:ext>
-            </a:extLst>
-          </p:cNvPr>
-          <p:cNvSpPr txBox="1"/>
-          <p:nvPr/>
-        </p:nvSpPr>
-        <p:spPr>
-          <a:xfrm>
-            <a:off x="7347625" y="3351075"/>
-            <a:ext cx="3040128" cy="646331"/>
-          </a:xfrm>
-          <a:prstGeom prst="rect">
-            <a:avLst/>
-          </a:prstGeom>
-          <a:noFill/>
-        </p:spPr>
-        <p:txBody>
-          <a:bodyPr wrap="none" rtlCol="0" anchor="ctr" anchorCtr="1">
-            <a:spAutoFit/>
-          </a:bodyPr>
-          <a:lstStyle/>
-          <a:p>
-            <a:r>
-              <a:rPr lang="en-US" dirty="0">
-                <a:solidFill>
-                  <a:srgbClr val="FFFF00"/>
-                </a:solidFill>
-                <a:ea typeface="標楷體" pitchFamily="65" charset="-120"/>
-                <a:cs typeface="Calibri" pitchFamily="34" charset="0"/>
-              </a:rPr>
-              <a:t>2 LSB of Opcode are 11 for </a:t>
-            </a:r>
-          </a:p>
-          <a:p>
-            <a:r>
-              <a:rPr lang="en-US" dirty="0">
-                <a:solidFill>
-                  <a:srgbClr val="FFFF00"/>
-                </a:solidFill>
-                <a:ea typeface="標楷體" pitchFamily="65" charset="-120"/>
-                <a:cs typeface="Calibri" pitchFamily="34" charset="0"/>
-              </a:rPr>
-              <a:t>RV32I </a:t>
-            </a:r>
-          </a:p>
-        </p:txBody>
-      </p:sp>
-      <p:cxnSp>
-        <p:nvCxnSpPr>
-          <p:cNvPr id="11" name="Straight Arrow Connector 10">
-            <a:extLst>
-              <a:ext uri="{FF2B5EF4-FFF2-40B4-BE49-F238E27FC236}">
-                <a16:creationId xmlns:a16="http://schemas.microsoft.com/office/drawing/2014/main" id="{E3E51C83-7064-4373-BB13-BB0C95B78ACF}"/>
-              </a:ext>
-            </a:extLst>
-          </p:cNvPr>
-          <p:cNvCxnSpPr/>
-          <p:nvPr/>
-        </p:nvCxnSpPr>
-        <p:spPr bwMode="auto">
-          <a:xfrm>
-            <a:off x="432160" y="4747098"/>
-            <a:ext cx="1235413" cy="0"/>
-          </a:xfrm>
-          <a:prstGeom prst="straightConnector1">
-            <a:avLst/>
-          </a:prstGeom>
-          <a:noFill/>
-          <a:ln w="15875" cap="flat" cmpd="sng" algn="ctr">
-            <a:solidFill>
-              <a:srgbClr val="FF0000"/>
-            </a:solidFill>
-            <a:prstDash val="solid"/>
-            <a:round/>
-            <a:headEnd type="none" w="med" len="med"/>
-            <a:tailEnd type="triangle"/>
-          </a:ln>
-          <a:effectLst/>
-        </p:spPr>
-      </p:cxnSp>
-      <p:cxnSp>
-        <p:nvCxnSpPr>
-          <p:cNvPr id="12" name="Straight Arrow Connector 11">
-            <a:extLst>
-              <a:ext uri="{FF2B5EF4-FFF2-40B4-BE49-F238E27FC236}">
-                <a16:creationId xmlns:a16="http://schemas.microsoft.com/office/drawing/2014/main" id="{F1EC76AC-5863-4F36-8053-1DCDA7D2B914}"/>
-              </a:ext>
-            </a:extLst>
-          </p:cNvPr>
-          <p:cNvCxnSpPr/>
-          <p:nvPr/>
-        </p:nvCxnSpPr>
-        <p:spPr bwMode="auto">
-          <a:xfrm>
-            <a:off x="432160" y="5064868"/>
-            <a:ext cx="1235413" cy="0"/>
-          </a:xfrm>
-          <a:prstGeom prst="straightConnector1">
-            <a:avLst/>
-          </a:prstGeom>
-          <a:noFill/>
-          <a:ln w="15875" cap="flat" cmpd="sng" algn="ctr">
-            <a:solidFill>
-              <a:srgbClr val="FF0000"/>
-            </a:solidFill>
-            <a:prstDash val="solid"/>
-            <a:round/>
-            <a:headEnd type="none" w="med" len="med"/>
-            <a:tailEnd type="triangle"/>
-          </a:ln>
-          <a:effectLst/>
-        </p:spPr>
-      </p:cxnSp>
-      <p:cxnSp>
-        <p:nvCxnSpPr>
-          <p:cNvPr id="13" name="Straight Arrow Connector 12">
-            <a:extLst>
-              <a:ext uri="{FF2B5EF4-FFF2-40B4-BE49-F238E27FC236}">
-                <a16:creationId xmlns:a16="http://schemas.microsoft.com/office/drawing/2014/main" id="{ED9300D4-6C08-48B0-A725-4D7F9F628273}"/>
-              </a:ext>
-            </a:extLst>
-          </p:cNvPr>
-          <p:cNvCxnSpPr/>
-          <p:nvPr/>
-        </p:nvCxnSpPr>
-        <p:spPr bwMode="auto">
-          <a:xfrm>
-            <a:off x="360824" y="5966298"/>
-            <a:ext cx="1235413" cy="0"/>
-          </a:xfrm>
-          <a:prstGeom prst="straightConnector1">
-            <a:avLst/>
-          </a:prstGeom>
-          <a:noFill/>
-          <a:ln w="15875" cap="flat" cmpd="sng" algn="ctr">
-            <a:solidFill>
-              <a:srgbClr val="FF0000"/>
-            </a:solidFill>
-            <a:prstDash val="solid"/>
-            <a:round/>
-            <a:headEnd type="none" w="med" len="med"/>
-            <a:tailEnd type="triangle"/>
-          </a:ln>
-          <a:effectLst/>
-        </p:spPr>
-      </p:cxnSp>
-    </p:spTree>
-    <p:extLst>
-      <p:ext uri="{BB962C8B-B14F-4D97-AF65-F5344CB8AC3E}">
-        <p14:creationId xmlns:p14="http://schemas.microsoft.com/office/powerpoint/2010/main" val="1802534501"/>
-      </p:ext>
-    </p:extLst>
-  </p:cSld>
-  <p:clrMapOvr>
-    <a:masterClrMapping/>
-  </p:clrMapOvr>
-</p:sld>
-</file>
-
-<file path=ppt/slides/slide15.xml><?xml version="1.0" encoding="utf-8"?>
-<p:sld xmlns:a="http://schemas.openxmlformats.org/drawingml/2006/main" xmlns:r="http://schemas.openxmlformats.org/officeDocument/2006/relationships" xmlns:p="http://schemas.openxmlformats.org/presentationml/2006/main">
-  <p:cSld>
-    <p:spTree>
-      <p:nvGrpSpPr>
-        <p:cNvPr id="1" name=""/>
-        <p:cNvGrpSpPr/>
-        <p:nvPr/>
-      </p:nvGrpSpPr>
-      <p:grpSpPr>
-        <a:xfrm>
-          <a:off x="0" y="0"/>
-          <a:ext cx="0" cy="0"/>
-          <a:chOff x="0" y="0"/>
-          <a:chExt cx="0" cy="0"/>
-        </a:xfrm>
-      </p:grpSpPr>
-      <p:sp>
-        <p:nvSpPr>
-          <p:cNvPr id="5" name="标题 4"/>
-          <p:cNvSpPr>
-            <a:spLocks noGrp="1"/>
-          </p:cNvSpPr>
-          <p:nvPr>
-            <p:ph type="title"/>
-          </p:nvPr>
-        </p:nvSpPr>
-        <p:spPr/>
-        <p:txBody>
-          <a:bodyPr/>
-          <a:lstStyle/>
-          <a:p>
-            <a:r>
-              <a:rPr lang="en-US" altLang="zh-CN" sz="4000" dirty="0"/>
-              <a:t>Example: How to decode the add instruction?</a:t>
-            </a:r>
-          </a:p>
-        </p:txBody>
-      </p:sp>
-      <p:sp>
-        <p:nvSpPr>
-          <p:cNvPr id="4" name="灯片编号占位符 3"/>
-          <p:cNvSpPr>
-            <a:spLocks noGrp="1"/>
-          </p:cNvSpPr>
-          <p:nvPr>
-            <p:ph type="sldNum" sz="quarter" idx="10"/>
-          </p:nvPr>
-        </p:nvSpPr>
-        <p:spPr/>
-        <p:txBody>
-          <a:bodyPr/>
-          <a:lstStyle/>
-          <a:p>
-            <a:pPr defTabSz="1219170"/>
-            <a:fld id="{D9B6BDF2-6896-4B98-8776-C18582F63BA5}" type="slidenum">
-              <a:rPr lang="zh-TW" altLang="en-US">
-                <a:solidFill>
-                  <a:prstClr val="white"/>
-                </a:solidFill>
-              </a:rPr>
-              <a:pPr defTabSz="1219170"/>
-              <a:t>15</a:t>
-            </a:fld>
-            <a:endParaRPr lang="zh-TW" altLang="en-US">
-              <a:solidFill>
-                <a:prstClr val="white"/>
-              </a:solidFill>
-            </a:endParaRPr>
-          </a:p>
-        </p:txBody>
-      </p:sp>
-      <p:pic>
-        <p:nvPicPr>
-          <p:cNvPr id="3" name="Picture 2">
-            <a:extLst>
-              <a:ext uri="{FF2B5EF4-FFF2-40B4-BE49-F238E27FC236}">
-                <a16:creationId xmlns:a16="http://schemas.microsoft.com/office/drawing/2014/main" id="{DE104EA9-E201-4010-ACD0-2AAA895C5120}"/>
-              </a:ext>
-            </a:extLst>
-          </p:cNvPr>
-          <p:cNvPicPr>
-            <a:picLocks noChangeAspect="1"/>
-          </p:cNvPicPr>
-          <p:nvPr/>
-        </p:nvPicPr>
-        <p:blipFill>
-          <a:blip r:embed="rId3"/>
-          <a:stretch>
-            <a:fillRect/>
-          </a:stretch>
-        </p:blipFill>
-        <p:spPr>
-          <a:xfrm>
-            <a:off x="1013614" y="969158"/>
-            <a:ext cx="9516803" cy="5285728"/>
-          </a:xfrm>
-          <a:prstGeom prst="rect">
-            <a:avLst/>
-          </a:prstGeom>
-        </p:spPr>
-      </p:pic>
-    </p:spTree>
-    <p:extLst>
-      <p:ext uri="{BB962C8B-B14F-4D97-AF65-F5344CB8AC3E}">
-        <p14:creationId xmlns:p14="http://schemas.microsoft.com/office/powerpoint/2010/main" val="3947637812"/>
-      </p:ext>
-    </p:extLst>
-  </p:cSld>
-  <p:clrMapOvr>
-    <a:masterClrMapping/>
-  </p:clrMapOvr>
-</p:sld>
-</file>
-
-<file path=ppt/slides/slide16.xml><?xml version="1.0" encoding="utf-8"?>
-<p:sld xmlns:a="http://schemas.openxmlformats.org/drawingml/2006/main" xmlns:r="http://schemas.openxmlformats.org/officeDocument/2006/relationships" xmlns:p="http://schemas.openxmlformats.org/presentationml/2006/main">
-  <p:cSld>
-    <p:spTree>
-      <p:nvGrpSpPr>
-        <p:cNvPr id="1" name=""/>
-        <p:cNvGrpSpPr/>
-        <p:nvPr/>
-      </p:nvGrpSpPr>
-      <p:grpSpPr>
-        <a:xfrm>
-          <a:off x="0" y="0"/>
-          <a:ext cx="0" cy="0"/>
-          <a:chOff x="0" y="0"/>
-          <a:chExt cx="0" cy="0"/>
-        </a:xfrm>
-      </p:grpSpPr>
-      <p:sp>
-        <p:nvSpPr>
           <p:cNvPr id="75778" name="Rectangle 2"/>
           <p:cNvSpPr>
             <a:spLocks noGrp="1" noChangeArrowheads="1"/>
@@ -14048,7 +12513,7 @@
                 <a:tabLst/>
                 <a:defRPr/>
               </a:pPr>
-              <a:t>16</a:t>
+              <a:t>13</a:t>
             </a:fld>
             <a:endParaRPr kumimoji="0" lang="zh-TW" altLang="en-US" sz="1200" b="0" i="0" u="none" strike="noStrike" kern="1200" cap="none" spc="0" normalizeH="0" baseline="0" noProof="0">
               <a:ln>
@@ -14080,7 +12545,7 @@
 </p:sld>
 </file>
 
-<file path=ppt/slides/slide17.xml><?xml version="1.0" encoding="utf-8"?>
+<file path=ppt/slides/slide14.xml><?xml version="1.0" encoding="utf-8"?>
 <p:sld xmlns:a="http://schemas.openxmlformats.org/drawingml/2006/main" xmlns:r="http://schemas.openxmlformats.org/officeDocument/2006/relationships" xmlns:p="http://schemas.openxmlformats.org/presentationml/2006/main">
   <p:cSld>
     <p:spTree>
@@ -14323,7 +12788,7 @@
                 <a:tabLst/>
                 <a:defRPr/>
               </a:pPr>
-              <a:t>17</a:t>
+              <a:t>14</a:t>
             </a:fld>
             <a:endParaRPr kumimoji="0" lang="zh-TW" altLang="en-US" sz="1200" b="0" i="0" u="none" strike="noStrike" kern="1200" cap="none" spc="0" normalizeH="0" baseline="0" noProof="0">
               <a:ln>
@@ -24686,7 +23151,31 @@
               <a:rPr lang="en-AU" altLang="zh-TW" sz="2400" dirty="0">
                 <a:ea typeface="新細明體" panose="02020500000000000000" pitchFamily="18" charset="-120"/>
               </a:rPr>
-              <a:t> VHDL, can be used to specify the control signals.  HDL codes are hardware-synthesizable. Feed them to a design compiler (Synopsis and Cadence tools) to get a netlist.</a:t>
+              <a:t> VHDL, can be used to specify the control signals.  HDL codes are hardware-synthesizable. Feed them </a:t>
+            </a:r>
+            <a:r>
+              <a:rPr lang="en-US" altLang="zh-TW" sz="2400" dirty="0">
+                <a:ea typeface="新細明體" panose="02020500000000000000" pitchFamily="18" charset="-120"/>
+              </a:rPr>
+              <a:t>into a design compiler (Synopsys and Cadence tools) to get a </a:t>
+            </a:r>
+            <a:r>
+              <a:rPr lang="en-US" altLang="zh-TW" sz="2400" b="1" dirty="0">
+                <a:ea typeface="新細明體" panose="02020500000000000000" pitchFamily="18" charset="-120"/>
+              </a:rPr>
+              <a:t>netlist</a:t>
+            </a:r>
+            <a:r>
+              <a:rPr lang="en-US" altLang="zh-TW" sz="2400" dirty="0">
+                <a:ea typeface="新細明體" panose="02020500000000000000" pitchFamily="18" charset="-120"/>
+              </a:rPr>
+              <a:t> (a graphical logic representation</a:t>
+            </a:r>
+            <a:r>
+              <a:rPr lang="en-AU" altLang="zh-TW" sz="2400" dirty="0">
+                <a:ea typeface="新細明體" panose="02020500000000000000" pitchFamily="18" charset="-120"/>
+              </a:rPr>
+              <a:t>).</a:t>
             </a:r>
           </a:p>
           <a:p>
@@ -24815,30 +23304,6 @@
               <a:rPr lang="en-US" altLang="zh-TW" dirty="0" err="1">
                 <a:ea typeface="新細明體" panose="02020500000000000000" pitchFamily="18" charset="-120"/>
               </a:rPr>
-              <a:t>ALUsel</a:t>
-            </a:r>
-            <a:r>
-              <a:rPr lang="en-US" altLang="zh-TW" dirty="0">
-                <a:ea typeface="新細明體" panose="02020500000000000000" pitchFamily="18" charset="-120"/>
-              </a:rPr>
-              <a:t> or </a:t>
-            </a:r>
-            <a:r>
-              <a:rPr lang="en-US" altLang="zh-TW" dirty="0" err="1">
-                <a:ea typeface="新細明體" panose="02020500000000000000" pitchFamily="18" charset="-120"/>
-              </a:rPr>
-              <a:t>ALUop</a:t>
-            </a:r>
-            <a:r>
-              <a:rPr lang="en-US" altLang="zh-TW" dirty="0">
-                <a:ea typeface="新細明體" panose="02020500000000000000" pitchFamily="18" charset="-120"/>
-              </a:rPr>
-              <a:t> or </a:t>
-            </a:r>
-            <a:r>
-              <a:rPr lang="en-US" altLang="zh-TW" dirty="0" err="1">
-                <a:ea typeface="新細明體" panose="02020500000000000000" pitchFamily="18" charset="-120"/>
-              </a:rPr>
               <a:t>ALUcontrol</a:t>
             </a:r>
             <a:endParaRPr lang="en-AU" altLang="zh-TW" dirty="0">
@@ -24860,7 +23325,7 @@
         <p:spPr>
           <a:xfrm>
             <a:off x="507460" y="1040859"/>
-            <a:ext cx="11177080" cy="5642968"/>
+            <a:ext cx="11589290" cy="5642968"/>
           </a:xfrm>
         </p:spPr>
         <p:txBody>
@@ -24868,48 +23333,40 @@
           <a:lstStyle/>
           <a:p>
             <a:r>
-              <a:rPr lang="en-AU" altLang="zh-TW" sz="2400" dirty="0" err="1">
+              <a:rPr lang="en-AU" altLang="zh-TW" sz="2200" dirty="0" err="1">
+                <a:ea typeface="新細明體" panose="02020500000000000000" pitchFamily="18" charset="-120"/>
+              </a:rPr>
+              <a:t>ALUcontrol</a:t>
+            </a:r>
+            <a:r>
+              <a:rPr lang="en-AU" altLang="zh-TW" sz="2200" dirty="0">
+                <a:ea typeface="新細明體" panose="02020500000000000000" pitchFamily="18" charset="-120"/>
+              </a:rPr>
+              <a:t> signal depends on a) operation type  (</a:t>
+            </a:r>
+            <a:r>
+              <a:rPr lang="en-AU" altLang="zh-TW" sz="2200" dirty="0" err="1">
                 <a:ea typeface="新細明體" panose="02020500000000000000" pitchFamily="18" charset="-120"/>
               </a:rPr>
               <a:t>ALUop</a:t>
             </a:r>
             <a:r>
-              <a:rPr lang="en-AU" altLang="zh-TW" sz="2400" dirty="0">
+              <a:rPr lang="en-AU" altLang="zh-TW" sz="2200" dirty="0">
                 <a:ea typeface="新細明體" panose="02020500000000000000" pitchFamily="18" charset="-120"/>
               </a:rPr>
-              <a:t> signal depends on </a:t>
+              <a:t>) and  b) funct3 and funct7 bits</a:t>
             </a:r>
           </a:p>
           <a:p>
             <a:pPr marL="0" indent="0">
               <a:buNone/>
             </a:pPr>
-            <a:r>
-              <a:rPr lang="en-AU" altLang="zh-TW" sz="2400" dirty="0">
-                <a:ea typeface="新細明體" panose="02020500000000000000" pitchFamily="18" charset="-120"/>
-              </a:rPr>
-              <a:t>	a) operation </a:t>
-            </a:r>
-            <a:r>
-              <a:rPr lang="en-AU" altLang="zh-TW" sz="2400">
-                <a:ea typeface="新細明體" panose="02020500000000000000" pitchFamily="18" charset="-120"/>
-              </a:rPr>
-              <a:t>type  and  b</a:t>
-            </a:r>
-            <a:r>
-              <a:rPr lang="en-AU" altLang="zh-TW" sz="2400" dirty="0">
-                <a:ea typeface="新細明體" panose="02020500000000000000" pitchFamily="18" charset="-120"/>
-              </a:rPr>
-              <a:t>) funct3 </a:t>
-            </a:r>
-            <a:r>
-              <a:rPr lang="en-AU" altLang="zh-TW" sz="2400">
-                <a:ea typeface="新細明體" panose="02020500000000000000" pitchFamily="18" charset="-120"/>
-              </a:rPr>
-              <a:t>and funct7 bits</a:t>
-            </a:r>
-            <a:endParaRPr lang="en-AU" altLang="zh-TW" sz="2400" dirty="0">
-              <a:ea typeface="新細明體" panose="02020500000000000000" pitchFamily="18" charset="-120"/>
+            <a:endParaRPr lang="en-US" sz="1100" b="0" i="0" dirty="0">
+              <a:solidFill>
+                <a:srgbClr val="E45649"/>
+              </a:solidFill>
+              <a:effectLst/>
+              <a:latin typeface="Fira Code" panose="020B0809050000020004" pitchFamily="49" charset="0"/>
             </a:endParaRPr>
           </a:p>
           <a:p>
@@ -24917,14 +23374,119 @@
               <a:buNone/>
             </a:pPr>
             <a:r>
-              <a:rPr lang="en-US" sz="1400" b="0" i="0" dirty="0">
-                <a:solidFill>
-                  <a:srgbClr val="383A42"/>
+              <a:rPr lang="en-US" sz="1400" b="0" i="0" dirty="0" err="1">
+                <a:solidFill>
+                  <a:srgbClr val="E45649"/>
                 </a:solidFill>
                 <a:effectLst/>
                 <a:latin typeface="Fira Code" panose="020B0809050000020004" pitchFamily="49" charset="0"/>
               </a:rPr>
-              <a:t>words </a:t>
+              <a:t>always_comb</a:t>
+            </a:r>
+            <a:r>
+              <a:rPr lang="en-US" sz="1400" b="0" i="0" dirty="0">
+                <a:solidFill>
+                  <a:srgbClr val="383A42"/>
+                </a:solidFill>
+                <a:effectLst/>
+                <a:latin typeface="Fira Code" panose="020B0809050000020004" pitchFamily="49" charset="0"/>
+              </a:rPr>
+              <a:t> </a:t>
+            </a:r>
+            <a:r>
+              <a:rPr lang="en-US" sz="1400" b="0" i="0" dirty="0">
+                <a:solidFill>
+                  <a:srgbClr val="A626A4"/>
+                </a:solidFill>
+                <a:effectLst/>
+                <a:latin typeface="Fira Code" panose="020B0809050000020004" pitchFamily="49" charset="0"/>
+              </a:rPr>
+              <a:t>begin</a:t>
+            </a:r>
+            <a:r>
+              <a:rPr lang="en-US" sz="1400" b="0" i="0" dirty="0">
+                <a:solidFill>
+                  <a:srgbClr val="383A42"/>
+                </a:solidFill>
+                <a:effectLst/>
+                <a:latin typeface="Fira Code" panose="020B0809050000020004" pitchFamily="49" charset="0"/>
+              </a:rPr>
+              <a:t> </a:t>
+            </a:r>
+            <a:r>
+              <a:rPr lang="en-US" sz="1400" b="0" i="0" dirty="0">
+                <a:solidFill>
+                  <a:srgbClr val="A626A4"/>
+                </a:solidFill>
+                <a:effectLst/>
+                <a:latin typeface="Fira Code" panose="020B0809050000020004" pitchFamily="49" charset="0"/>
+              </a:rPr>
+              <a:t>case</a:t>
+            </a:r>
+            <a:r>
+              <a:rPr lang="en-US" sz="1400" b="0" i="0" dirty="0">
+                <a:solidFill>
+                  <a:srgbClr val="383A42"/>
+                </a:solidFill>
+                <a:effectLst/>
+                <a:latin typeface="Fira Code" panose="020B0809050000020004" pitchFamily="49" charset="0"/>
+              </a:rPr>
+              <a:t> (</a:t>
+            </a:r>
+            <a:r>
+              <a:rPr lang="en-US" sz="1400" b="0" i="0" dirty="0" err="1">
+                <a:solidFill>
+                  <a:srgbClr val="383A42"/>
+                </a:solidFill>
+                <a:effectLst/>
+                <a:latin typeface="Fira Code" panose="020B0809050000020004" pitchFamily="49" charset="0"/>
+              </a:rPr>
+              <a:t>alu_op</a:t>
+            </a:r>
+            <a:r>
+              <a:rPr lang="en-US" sz="1400" b="0" i="0" dirty="0">
+                <a:solidFill>
+                  <a:srgbClr val="383A42"/>
+                </a:solidFill>
+                <a:effectLst/>
+                <a:latin typeface="Fira Code" panose="020B0809050000020004" pitchFamily="49" charset="0"/>
+              </a:rPr>
+              <a:t>) </a:t>
+            </a:r>
+          </a:p>
+          <a:p>
+            <a:pPr marL="0" indent="0">
+              <a:buNone/>
+            </a:pPr>
+            <a:r>
+              <a:rPr lang="en-US" sz="1400" b="0" i="0" dirty="0">
+                <a:solidFill>
+                  <a:srgbClr val="383A42"/>
+                </a:solidFill>
+                <a:effectLst/>
+                <a:latin typeface="Fira Code" panose="020B0809050000020004" pitchFamily="49" charset="0"/>
+              </a:rPr>
+              <a:t>	</a:t>
+            </a:r>
+            <a:r>
+              <a:rPr lang="en-US" sz="1400" b="0" i="0" dirty="0">
+                <a:solidFill>
+                  <a:srgbClr val="B76B01"/>
+                </a:solidFill>
+                <a:effectLst/>
+                <a:latin typeface="Fira Code" panose="020B0809050000020004" pitchFamily="49" charset="0"/>
+              </a:rPr>
+              <a:t>2'b00</a:t>
+            </a:r>
+            <a:r>
+              <a:rPr lang="en-US" sz="1400" b="0" i="0" dirty="0">
+                <a:solidFill>
+                  <a:srgbClr val="383A42"/>
+                </a:solidFill>
+                <a:effectLst/>
+                <a:latin typeface="Fira Code" panose="020B0809050000020004" pitchFamily="49" charset="0"/>
+              </a:rPr>
+              <a:t>: </a:t>
             </a:r>
             <a:r>
               <a:rPr lang="en-US" sz="1400" b="0" i="0" dirty="0" err="1">
@@ -24964,7 +23526,7 @@
                 <a:effectLst/>
                 <a:latin typeface="Fira Code" panose="020B0809050000020004" pitchFamily="49" charset="0"/>
               </a:rPr>
-              <a:t> [ </a:t>
+              <a:t> ALU_ADD; </a:t>
             </a:r>
           </a:p>
           <a:p>
@@ -24972,10 +23534,11 @@
               <a:buNone/>
             </a:pPr>
             <a:r>
-              <a:rPr lang="en-US" sz="1400" dirty="0">
+              <a:rPr lang="en-US" sz="1400" b="0" i="0" dirty="0">
                 <a:solidFill>
                   <a:srgbClr val="383A42"/>
                 </a:solidFill>
+                <a:effectLst/>
                 <a:latin typeface="Fira Code" panose="020B0809050000020004" pitchFamily="49" charset="0"/>
               </a:rPr>
               <a:t>	</a:t>
@@ -24983,47 +23546,37 @@
             <a:r>
               <a:rPr lang="en-US" sz="1400" b="0" i="0" dirty="0">
                 <a:solidFill>
-                  <a:srgbClr val="E45649"/>
+                  <a:srgbClr val="B76B01"/>
                 </a:solidFill>
                 <a:effectLst/>
                 <a:latin typeface="Fira Code" panose="020B0809050000020004" pitchFamily="49" charset="0"/>
               </a:rPr>
-              <a:t># If </a:t>
-            </a:r>
-            <a:r>
-              <a:rPr lang="en-US" sz="1400" b="0" i="0" dirty="0" err="1">
-                <a:solidFill>
-                  <a:srgbClr val="E45649"/>
+              <a:t>2'b01</a:t>
+            </a:r>
+            <a:r>
+              <a:rPr lang="en-US" sz="1400" b="0" i="0" dirty="0">
+                <a:solidFill>
+                  <a:srgbClr val="383A42"/>
                 </a:solidFill>
                 <a:effectLst/>
                 <a:latin typeface="Fira Code" panose="020B0809050000020004" pitchFamily="49" charset="0"/>
               </a:rPr>
-              <a:t>ALUOp</a:t>
-            </a:r>
-            <a:r>
-              <a:rPr lang="en-US" sz="1400" b="0" i="0" dirty="0">
-                <a:solidFill>
-                  <a:srgbClr val="E45649"/>
+              <a:t>: </a:t>
+            </a:r>
+            <a:r>
+              <a:rPr lang="en-US" sz="1400" b="0" i="0" dirty="0" err="1">
+                <a:solidFill>
+                  <a:srgbClr val="383A42"/>
                 </a:solidFill>
                 <a:effectLst/>
                 <a:latin typeface="Fira Code" panose="020B0809050000020004" pitchFamily="49" charset="0"/>
               </a:rPr>
-              <a:t> is </a:t>
+              <a:t>alu_control</a:t>
             </a:r>
             <a:r>
               <a:rPr lang="en-US" sz="1400" b="0" i="0" dirty="0">
                 <a:solidFill>
-                  <a:srgbClr val="B76B01"/>
-                </a:solidFill>
-                <a:effectLst/>
-                <a:latin typeface="Fira Code" panose="020B0809050000020004" pitchFamily="49" charset="0"/>
-              </a:rPr>
-              <a:t>00</a:t>
-            </a:r>
-            <a:r>
-              <a:rPr lang="en-US" sz="1400" b="0" i="0" dirty="0">
-                <a:solidFill>
-                  <a:srgbClr val="E45649"/>
+                  <a:srgbClr val="383A42"/>
                 </a:solidFill>
                 <a:effectLst/>
                 <a:latin typeface="Fira Code" panose="020B0809050000020004" pitchFamily="49" charset="0"/>
@@ -25033,57 +23586,71 @@
             <a:r>
               <a:rPr lang="en-US" sz="1400" b="0" i="0" dirty="0">
                 <a:solidFill>
-                  <a:srgbClr val="383A42"/>
+                  <a:srgbClr val="4078F2"/>
                 </a:solidFill>
                 <a:effectLst/>
                 <a:latin typeface="Fira Code" panose="020B0809050000020004" pitchFamily="49" charset="0"/>
               </a:rPr>
-              <a:t>(</a:t>
+              <a:t>=</a:t>
             </a:r>
             <a:r>
               <a:rPr lang="en-US" sz="1400" b="0" i="0" dirty="0">
                 <a:solidFill>
-                  <a:srgbClr val="E45649"/>
+                  <a:srgbClr val="383A42"/>
                 </a:solidFill>
                 <a:effectLst/>
                 <a:latin typeface="Fira Code" panose="020B0809050000020004" pitchFamily="49" charset="0"/>
               </a:rPr>
-              <a:t>Load</a:t>
+              <a:t> ALU_SUB; </a:t>
+            </a:r>
+          </a:p>
+          <a:p>
+            <a:pPr marL="0" indent="0">
+              <a:buNone/>
+            </a:pPr>
+            <a:r>
+              <a:rPr lang="en-US" sz="1400" dirty="0">
+                <a:solidFill>
+                  <a:srgbClr val="383A42"/>
+                </a:solidFill>
+                <a:latin typeface="Fira Code" panose="020B0809050000020004" pitchFamily="49" charset="0"/>
+              </a:rPr>
+              <a:t>	</a:t>
             </a:r>
             <a:r>
               <a:rPr lang="en-US" sz="1400" b="0" i="0" dirty="0">
                 <a:solidFill>
-                  <a:srgbClr val="4078F2"/>
+                  <a:srgbClr val="B76B01"/>
                 </a:solidFill>
                 <a:effectLst/>
                 <a:latin typeface="Fira Code" panose="020B0809050000020004" pitchFamily="49" charset="0"/>
               </a:rPr>
-              <a:t>/</a:t>
+              <a:t>2'b10</a:t>
             </a:r>
             <a:r>
               <a:rPr lang="en-US" sz="1400" b="0" i="0" dirty="0">
                 <a:solidFill>
-                  <a:srgbClr val="E45649"/>
+                  <a:srgbClr val="383A42"/>
                 </a:solidFill>
                 <a:effectLst/>
                 <a:latin typeface="Fira Code" panose="020B0809050000020004" pitchFamily="49" charset="0"/>
               </a:rPr>
-              <a:t>Store</a:t>
+              <a:t>: </a:t>
             </a:r>
             <a:r>
               <a:rPr lang="en-US" sz="1400" b="0" i="0" dirty="0">
                 <a:solidFill>
-                  <a:srgbClr val="383A42"/>
+                  <a:srgbClr val="A626A4"/>
                 </a:solidFill>
                 <a:effectLst/>
                 <a:latin typeface="Fira Code" panose="020B0809050000020004" pitchFamily="49" charset="0"/>
               </a:rPr>
-              <a:t>),</a:t>
+              <a:t>begin</a:t>
             </a:r>
             <a:r>
               <a:rPr lang="en-US" sz="1400" b="0" i="0" dirty="0">
                 <a:solidFill>
-                  <a:srgbClr val="E45649"/>
+                  <a:srgbClr val="383A42"/>
                 </a:solidFill>
                 <a:effectLst/>
                 <a:latin typeface="Fira Code" panose="020B0809050000020004" pitchFamily="49" charset="0"/>
@@ -25098,21 +23665,61 @@
             <a:r>
               <a:rPr lang="en-US" sz="1400" dirty="0">
                 <a:solidFill>
-                  <a:srgbClr val="E45649"/>
+                  <a:srgbClr val="383A42"/>
                 </a:solidFill>
                 <a:latin typeface="Fira Code" panose="020B0809050000020004" pitchFamily="49" charset="0"/>
               </a:rPr>
-              <a:t>	</a:t>
+              <a:t>		</a:t>
             </a:r>
             <a:r>
               <a:rPr lang="en-US" sz="1400" b="0" i="0" dirty="0">
                 <a:solidFill>
-                  <a:srgbClr val="E45649"/>
+                  <a:srgbClr val="A626A4"/>
                 </a:solidFill>
                 <a:effectLst/>
                 <a:latin typeface="Fira Code" panose="020B0809050000020004" pitchFamily="49" charset="0"/>
               </a:rPr>
-              <a:t>force ADD</a:t>
+              <a:t>case</a:t>
+            </a:r>
+            <a:r>
+              <a:rPr lang="en-US" sz="1400" b="0" i="0" dirty="0">
+                <a:solidFill>
+                  <a:srgbClr val="383A42"/>
+                </a:solidFill>
+                <a:effectLst/>
+                <a:latin typeface="Fira Code" panose="020B0809050000020004" pitchFamily="49" charset="0"/>
+              </a:rPr>
+              <a:t> (funct3) </a:t>
+            </a:r>
+            <a:r>
+              <a:rPr lang="en-US" sz="1400" b="0" i="0" dirty="0">
+                <a:solidFill>
+                  <a:srgbClr val="B76B01"/>
+                </a:solidFill>
+                <a:effectLst/>
+                <a:latin typeface="Fira Code" panose="020B0809050000020004" pitchFamily="49" charset="0"/>
+              </a:rPr>
+              <a:t>3'b000</a:t>
+            </a:r>
+            <a:r>
+              <a:rPr lang="en-US" sz="1400" b="0" i="0" dirty="0">
+                <a:solidFill>
+                  <a:srgbClr val="383A42"/>
+                </a:solidFill>
+                <a:effectLst/>
+                <a:latin typeface="Fira Code" panose="020B0809050000020004" pitchFamily="49" charset="0"/>
+              </a:rPr>
+              <a:t>: </a:t>
+            </a:r>
+            <a:r>
+              <a:rPr lang="en-US" sz="1400" b="0" i="0" dirty="0">
+                <a:solidFill>
+                  <a:srgbClr val="A626A4"/>
+                </a:solidFill>
+                <a:effectLst/>
+                <a:latin typeface="Fira Code" panose="020B0809050000020004" pitchFamily="49" charset="0"/>
+              </a:rPr>
+              <a:t>begin</a:t>
             </a:r>
             <a:r>
               <a:rPr lang="en-US" sz="1400" b="0" i="0" dirty="0">
@@ -25124,15 +23731,49 @@
               </a:rPr>
               <a:t> </a:t>
             </a:r>
-            <a:r>
-              <a:rPr lang="en-US" sz="1400" b="0" i="0" dirty="0" err="1">
+          </a:p>
+          <a:p>
+            <a:pPr marL="0" indent="0">
+              <a:buNone/>
+            </a:pPr>
+            <a:r>
+              <a:rPr lang="en-US" sz="1400" dirty="0">
                 <a:solidFill>
                   <a:srgbClr val="383A42"/>
+                </a:solidFill>
+                <a:latin typeface="Fira Code" panose="020B0809050000020004" pitchFamily="49" charset="0"/>
+              </a:rPr>
+              <a:t>				</a:t>
+            </a:r>
+            <a:r>
+              <a:rPr lang="en-US" sz="1400" b="0" i="0" dirty="0">
+                <a:solidFill>
+                  <a:srgbClr val="A626A4"/>
                 </a:solidFill>
                 <a:effectLst/>
                 <a:latin typeface="Fira Code" panose="020B0809050000020004" pitchFamily="49" charset="0"/>
               </a:rPr>
-              <a:t>alu_op</a:t>
+              <a:t>if</a:t>
+            </a:r>
+            <a:r>
+              <a:rPr lang="en-US" sz="1400" b="0" i="0" dirty="0">
+                <a:solidFill>
+                  <a:srgbClr val="383A42"/>
+                </a:solidFill>
+                <a:effectLst/>
+                <a:latin typeface="Fira Code" panose="020B0809050000020004" pitchFamily="49" charset="0"/>
+              </a:rPr>
+              <a:t> (funct7_bit5) </a:t>
+            </a:r>
+            <a:r>
+              <a:rPr lang="en-US" sz="1400" b="0" i="0" dirty="0" err="1">
+                <a:solidFill>
+                  <a:srgbClr val="383A42"/>
+                </a:solidFill>
+                <a:effectLst/>
+                <a:latin typeface="Fira Code" panose="020B0809050000020004" pitchFamily="49" charset="0"/>
+              </a:rPr>
+              <a:t>alu_control</a:t>
             </a:r>
             <a:r>
               <a:rPr lang="en-US" sz="1400" b="0" i="0" dirty="0">
@@ -25152,7 +23793,27 @@
                 <a:effectLst/>
                 <a:latin typeface="Fira Code" panose="020B0809050000020004" pitchFamily="49" charset="0"/>
               </a:rPr>
-              <a:t>==</a:t>
+              <a:t>=</a:t>
+            </a:r>
+            <a:r>
+              <a:rPr lang="en-US" sz="1400" b="0" i="0" dirty="0">
+                <a:solidFill>
+                  <a:srgbClr val="383A42"/>
+                </a:solidFill>
+                <a:effectLst/>
+                <a:latin typeface="Fira Code" panose="020B0809050000020004" pitchFamily="49" charset="0"/>
+              </a:rPr>
+              <a:t> ALU_SUB; </a:t>
+            </a:r>
+            <a:r>
+              <a:rPr lang="en-US" sz="1400" b="0" i="0" dirty="0">
+                <a:solidFill>
+                  <a:srgbClr val="A626A4"/>
+                </a:solidFill>
+                <a:effectLst/>
+                <a:latin typeface="Fira Code" panose="020B0809050000020004" pitchFamily="49" charset="0"/>
+              </a:rPr>
+              <a:t>else</a:t>
             </a:r>
             <a:r>
               <a:rPr lang="en-US" sz="1400" b="0" i="0" dirty="0">
@@ -25165,14 +23826,14 @@
               <a:t> </a:t>
             </a:r>
             <a:r>
-              <a:rPr lang="en-US" sz="1400" b="0" i="0" dirty="0">
-                <a:solidFill>
-                  <a:srgbClr val="B76B01"/>
+              <a:rPr lang="en-US" sz="1400" b="0" i="0" dirty="0" err="1">
+                <a:solidFill>
+                  <a:srgbClr val="383A42"/>
                 </a:solidFill>
                 <a:effectLst/>
                 <a:latin typeface="Fira Code" panose="020B0809050000020004" pitchFamily="49" charset="0"/>
               </a:rPr>
-              <a:t>2</a:t>
+              <a:t>alu_control</a:t>
             </a:r>
             <a:r>
               <a:rPr lang="en-US" sz="1400" b="0" i="0" dirty="0">
@@ -25182,7 +23843,7 @@
                 <a:effectLst/>
                 <a:latin typeface="Fira Code" panose="020B0809050000020004" pitchFamily="49" charset="0"/>
               </a:rPr>
-              <a:t>'b00 </a:t>
+              <a:t> </a:t>
             </a:r>
             <a:r>
               <a:rPr lang="en-US" sz="1400" b="0" i="0" dirty="0">
@@ -25192,7 +23853,7 @@
                 <a:effectLst/>
                 <a:latin typeface="Fira Code" panose="020B0809050000020004" pitchFamily="49" charset="0"/>
               </a:rPr>
-              <a:t>:</a:t>
+              <a:t>=</a:t>
             </a:r>
             <a:r>
               <a:rPr lang="en-US" sz="1400" b="0" i="0" dirty="0">
@@ -25204,133 +23865,109 @@
               </a:rPr>
               <a:t> ALU_ADD; </a:t>
             </a:r>
-          </a:p>
-          <a:p>
-            <a:pPr marL="0" indent="0">
-              <a:buNone/>
-            </a:pPr>
-            <a:r>
-              <a:rPr lang="en-US" sz="1400" dirty="0">
-                <a:solidFill>
-                  <a:srgbClr val="383A42"/>
-                </a:solidFill>
-                <a:latin typeface="Fira Code" panose="020B0809050000020004" pitchFamily="49" charset="0"/>
-              </a:rPr>
-              <a:t>	</a:t>
-            </a:r>
             <a:r>
               <a:rPr lang="en-US" sz="1400" b="0" i="0" dirty="0">
                 <a:solidFill>
-                  <a:srgbClr val="E45649"/>
+                  <a:srgbClr val="A626A4"/>
                 </a:solidFill>
                 <a:effectLst/>
                 <a:latin typeface="Fira Code" panose="020B0809050000020004" pitchFamily="49" charset="0"/>
               </a:rPr>
-              <a:t># If </a:t>
-            </a:r>
-            <a:r>
-              <a:rPr lang="en-US" sz="1400" b="0" i="0" dirty="0" err="1">
-                <a:solidFill>
-                  <a:srgbClr val="E45649"/>
-                </a:solidFill>
-                <a:effectLst/>
-                <a:latin typeface="Fira Code" panose="020B0809050000020004" pitchFamily="49" charset="0"/>
-              </a:rPr>
-              <a:t>ALUOp</a:t>
+              <a:t>end</a:t>
             </a:r>
             <a:r>
               <a:rPr lang="en-US" sz="1400" b="0" i="0" dirty="0">
                 <a:solidFill>
-                  <a:srgbClr val="E45649"/>
-                </a:solidFill>
-                <a:effectLst/>
-                <a:latin typeface="Fira Code" panose="020B0809050000020004" pitchFamily="49" charset="0"/>
-              </a:rPr>
-              <a:t> is </a:t>
-            </a:r>
-            <a:r>
-              <a:rPr lang="en-US" sz="1400" b="0" i="0" dirty="0">
-                <a:solidFill>
-                  <a:srgbClr val="B76B01"/>
-                </a:solidFill>
-                <a:effectLst/>
-                <a:latin typeface="Fira Code" panose="020B0809050000020004" pitchFamily="49" charset="0"/>
-              </a:rPr>
-              <a:t>01</a:t>
-            </a:r>
-            <a:r>
-              <a:rPr lang="en-US" sz="1400" b="0" i="0" dirty="0">
-                <a:solidFill>
-                  <a:srgbClr val="E45649"/>
+                  <a:srgbClr val="383A42"/>
                 </a:solidFill>
                 <a:effectLst/>
                 <a:latin typeface="Fira Code" panose="020B0809050000020004" pitchFamily="49" charset="0"/>
               </a:rPr>
               <a:t> </a:t>
             </a:r>
+          </a:p>
+          <a:p>
+            <a:pPr marL="0" indent="0">
+              <a:buNone/>
+            </a:pPr>
+            <a:r>
+              <a:rPr lang="en-US" sz="1400" dirty="0">
+                <a:solidFill>
+                  <a:srgbClr val="383A42"/>
+                </a:solidFill>
+                <a:latin typeface="Fira Code" panose="020B0809050000020004" pitchFamily="49" charset="0"/>
+              </a:rPr>
+              <a:t>			   </a:t>
+            </a:r>
             <a:r>
               <a:rPr lang="en-US" sz="1400" b="0" i="0" dirty="0">
                 <a:solidFill>
-                  <a:srgbClr val="383A42"/>
+                  <a:srgbClr val="B76B01"/>
                 </a:solidFill>
                 <a:effectLst/>
                 <a:latin typeface="Fira Code" panose="020B0809050000020004" pitchFamily="49" charset="0"/>
               </a:rPr>
-              <a:t>(</a:t>
+              <a:t>3'b001</a:t>
             </a:r>
             <a:r>
               <a:rPr lang="en-US" sz="1400" b="0" i="0" dirty="0">
                 <a:solidFill>
-                  <a:srgbClr val="E45649"/>
+                  <a:srgbClr val="383A42"/>
                 </a:solidFill>
                 <a:effectLst/>
                 <a:latin typeface="Fira Code" panose="020B0809050000020004" pitchFamily="49" charset="0"/>
               </a:rPr>
-              <a:t>Branch</a:t>
-            </a:r>
-            <a:r>
-              <a:rPr lang="en-US" sz="1400" b="0" i="0" dirty="0">
+              <a:t>: </a:t>
+            </a:r>
+            <a:r>
+              <a:rPr lang="en-US" sz="1400" b="0" i="0" dirty="0" err="1">
                 <a:solidFill>
                   <a:srgbClr val="383A42"/>
                 </a:solidFill>
                 <a:effectLst/>
                 <a:latin typeface="Fira Code" panose="020B0809050000020004" pitchFamily="49" charset="0"/>
               </a:rPr>
-              <a:t>),</a:t>
+              <a:t>alu_control</a:t>
             </a:r>
             <a:r>
               <a:rPr lang="en-US" sz="1400" b="0" i="0" dirty="0">
                 <a:solidFill>
-                  <a:srgbClr val="E45649"/>
+                  <a:srgbClr val="383A42"/>
                 </a:solidFill>
                 <a:effectLst/>
                 <a:latin typeface="Fira Code" panose="020B0809050000020004" pitchFamily="49" charset="0"/>
               </a:rPr>
               <a:t> </a:t>
             </a:r>
-          </a:p>
-          <a:p>
-            <a:pPr marL="0" indent="0">
-              <a:buNone/>
-            </a:pPr>
-            <a:r>
-              <a:rPr lang="en-US" sz="1400" dirty="0">
-                <a:solidFill>
-                  <a:srgbClr val="E45649"/>
-                </a:solidFill>
-                <a:latin typeface="Fira Code" panose="020B0809050000020004" pitchFamily="49" charset="0"/>
-              </a:rPr>
-              <a:t>	</a:t>
-            </a:r>
             <a:r>
               <a:rPr lang="en-US" sz="1400" b="0" i="0" dirty="0">
                 <a:solidFill>
-                  <a:srgbClr val="E45649"/>
+                  <a:srgbClr val="4078F2"/>
                 </a:solidFill>
                 <a:effectLst/>
                 <a:latin typeface="Fira Code" panose="020B0809050000020004" pitchFamily="49" charset="0"/>
               </a:rPr>
-              <a:t>force SUB</a:t>
+              <a:t>=</a:t>
+            </a:r>
+            <a:r>
+              <a:rPr lang="en-US" sz="1400" b="0" i="0" dirty="0">
+                <a:solidFill>
+                  <a:srgbClr val="383A42"/>
+                </a:solidFill>
+                <a:effectLst/>
+                <a:latin typeface="Fira Code" panose="020B0809050000020004" pitchFamily="49" charset="0"/>
+              </a:rPr>
+              <a:t> ALU_SLL; </a:t>
+            </a:r>
+            <a:r>
+              <a:rPr lang="en-US" sz="1400" b="0" i="1" dirty="0">
+                <a:solidFill>
+                  <a:srgbClr val="A0A1A7"/>
+                </a:solidFill>
+                <a:effectLst/>
+                <a:latin typeface="Fira Code" panose="020B0809050000020004" pitchFamily="49" charset="0"/>
+              </a:rPr>
+              <a:t>// SLL / SLLI</a:t>
             </a:r>
             <a:r>
               <a:rPr lang="en-US" sz="1400" b="0" i="0" dirty="0">
@@ -25342,15 +23979,49 @@
               </a:rPr>
               <a:t> </a:t>
             </a:r>
-            <a:r>
-              <a:rPr lang="en-US" sz="1400" b="0" i="0" dirty="0" err="1">
+          </a:p>
+          <a:p>
+            <a:pPr marL="0" indent="0">
+              <a:buNone/>
+            </a:pPr>
+            <a:r>
+              <a:rPr lang="en-US" sz="1400" dirty="0">
                 <a:solidFill>
                   <a:srgbClr val="383A42"/>
+                </a:solidFill>
+                <a:latin typeface="Fira Code" panose="020B0809050000020004" pitchFamily="49" charset="0"/>
+              </a:rPr>
+              <a:t>			   </a:t>
+            </a:r>
+            <a:r>
+              <a:rPr lang="en-US" sz="1400" b="0" i="0" dirty="0">
+                <a:solidFill>
+                  <a:srgbClr val="B76B01"/>
                 </a:solidFill>
                 <a:effectLst/>
                 <a:latin typeface="Fira Code" panose="020B0809050000020004" pitchFamily="49" charset="0"/>
               </a:rPr>
-              <a:t>alu_op</a:t>
+              <a:t>3'b010</a:t>
+            </a:r>
+            <a:r>
+              <a:rPr lang="en-US" sz="1400" b="0" i="0" dirty="0">
+                <a:solidFill>
+                  <a:srgbClr val="383A42"/>
+                </a:solidFill>
+                <a:effectLst/>
+                <a:latin typeface="Fira Code" panose="020B0809050000020004" pitchFamily="49" charset="0"/>
+              </a:rPr>
+              <a:t>: </a:t>
+            </a:r>
+            <a:r>
+              <a:rPr lang="en-US" sz="1400" b="0" i="0" dirty="0" err="1">
+                <a:solidFill>
+                  <a:srgbClr val="383A42"/>
+                </a:solidFill>
+                <a:effectLst/>
+                <a:latin typeface="Fira Code" panose="020B0809050000020004" pitchFamily="49" charset="0"/>
+              </a:rPr>
+              <a:t>alu_control</a:t>
             </a:r>
             <a:r>
               <a:rPr lang="en-US" sz="1400" b="0" i="0" dirty="0">
@@ -25370,7 +24041,27 @@
                 <a:effectLst/>
                 <a:latin typeface="Fira Code" panose="020B0809050000020004" pitchFamily="49" charset="0"/>
               </a:rPr>
-              <a:t>==</a:t>
+              <a:t>=</a:t>
+            </a:r>
+            <a:r>
+              <a:rPr lang="en-US" sz="1400" b="0" i="0" dirty="0">
+                <a:solidFill>
+                  <a:srgbClr val="383A42"/>
+                </a:solidFill>
+                <a:effectLst/>
+                <a:latin typeface="Fira Code" panose="020B0809050000020004" pitchFamily="49" charset="0"/>
+              </a:rPr>
+              <a:t> ALU_SLT; </a:t>
+            </a:r>
+            <a:r>
+              <a:rPr lang="en-US" sz="1400" b="0" i="1" dirty="0">
+                <a:solidFill>
+                  <a:srgbClr val="A0A1A7"/>
+                </a:solidFill>
+                <a:effectLst/>
+                <a:latin typeface="Fira Code" panose="020B0809050000020004" pitchFamily="49" charset="0"/>
+              </a:rPr>
+              <a:t>// SLT / SLTI</a:t>
             </a:r>
             <a:r>
               <a:rPr lang="en-US" sz="1400" b="0" i="0" dirty="0">
@@ -25382,6 +24073,20 @@
               </a:rPr>
               <a:t> </a:t>
             </a:r>
+          </a:p>
+          <a:p>
+            <a:pPr marL="0" indent="0">
+              <a:buNone/>
+            </a:pPr>
+            <a:r>
+              <a:rPr lang="en-US" sz="1400" dirty="0">
+                <a:solidFill>
+                  <a:srgbClr val="383A42"/>
+                </a:solidFill>
+                <a:latin typeface="Fira Code" panose="020B0809050000020004" pitchFamily="49" charset="0"/>
+              </a:rPr>
+              <a:t>			   </a:t>
+            </a:r>
             <a:r>
               <a:rPr lang="en-US" sz="1400" b="0" i="0" dirty="0">
                 <a:solidFill>
@@ -25390,7 +24095,7 @@
                 <a:effectLst/>
                 <a:latin typeface="Fira Code" panose="020B0809050000020004" pitchFamily="49" charset="0"/>
               </a:rPr>
-              <a:t>2</a:t>
+              <a:t>3'b100</a:t>
             </a:r>
             <a:r>
               <a:rPr lang="en-US" sz="1400" b="0" i="0" dirty="0">
@@ -25400,77 +24105,22 @@
                 <a:effectLst/>
                 <a:latin typeface="Fira Code" panose="020B0809050000020004" pitchFamily="49" charset="0"/>
               </a:rPr>
-              <a:t>'b01 </a:t>
-            </a:r>
-            <a:r>
-              <a:rPr lang="en-US" sz="1400" b="0" i="0" dirty="0">
-                <a:solidFill>
-                  <a:srgbClr val="4078F2"/>
+              <a:t>: </a:t>
+            </a:r>
+            <a:r>
+              <a:rPr lang="en-US" sz="1400" b="0" i="0" dirty="0" err="1">
+                <a:solidFill>
+                  <a:srgbClr val="383A42"/>
                 </a:solidFill>
                 <a:effectLst/>
                 <a:latin typeface="Fira Code" panose="020B0809050000020004" pitchFamily="49" charset="0"/>
               </a:rPr>
-              <a:t>:</a:t>
+              <a:t>alu_control</a:t>
             </a:r>
             <a:r>
               <a:rPr lang="en-US" sz="1400" b="0" i="0" dirty="0">
                 <a:solidFill>
                   <a:srgbClr val="383A42"/>
-                </a:solidFill>
-                <a:effectLst/>
-                <a:latin typeface="Fira Code" panose="020B0809050000020004" pitchFamily="49" charset="0"/>
-              </a:rPr>
-              <a:t> ALU_SUB; </a:t>
-            </a:r>
-          </a:p>
-          <a:p>
-            <a:pPr marL="0" indent="0">
-              <a:buNone/>
-            </a:pPr>
-            <a:r>
-              <a:rPr lang="en-US" sz="1400" b="0" i="0" dirty="0">
-                <a:solidFill>
-                  <a:srgbClr val="E45649"/>
-                </a:solidFill>
-                <a:effectLst/>
-                <a:latin typeface="Fira Code" panose="020B0809050000020004" pitchFamily="49" charset="0"/>
-              </a:rPr>
-              <a:t># If </a:t>
-            </a:r>
-            <a:r>
-              <a:rPr lang="en-US" sz="1400" b="0" i="0" dirty="0" err="1">
-                <a:solidFill>
-                  <a:srgbClr val="E45649"/>
-                </a:solidFill>
-                <a:effectLst/>
-                <a:latin typeface="Fira Code" panose="020B0809050000020004" pitchFamily="49" charset="0"/>
-              </a:rPr>
-              <a:t>ALUOp</a:t>
-            </a:r>
-            <a:r>
-              <a:rPr lang="en-US" sz="1400" b="0" i="0" dirty="0">
-                <a:solidFill>
-                  <a:srgbClr val="E45649"/>
-                </a:solidFill>
-                <a:effectLst/>
-                <a:latin typeface="Fira Code" panose="020B0809050000020004" pitchFamily="49" charset="0"/>
-              </a:rPr>
-              <a:t> is </a:t>
-            </a:r>
-            <a:r>
-              <a:rPr lang="en-US" sz="1400" b="0" i="0" dirty="0">
-                <a:solidFill>
-                  <a:srgbClr val="B76B01"/>
-                </a:solidFill>
-                <a:effectLst/>
-                <a:latin typeface="Fira Code" panose="020B0809050000020004" pitchFamily="49" charset="0"/>
-              </a:rPr>
-              <a:t>10</a:t>
-            </a:r>
-            <a:r>
-              <a:rPr lang="en-US" sz="1400" b="0" i="0" dirty="0">
-                <a:solidFill>
-                  <a:srgbClr val="E45649"/>
                 </a:solidFill>
                 <a:effectLst/>
                 <a:latin typeface="Fira Code" panose="020B0809050000020004" pitchFamily="49" charset="0"/>
@@ -25480,96 +24130,32 @@
             <a:r>
               <a:rPr lang="en-US" sz="1400" b="0" i="0" dirty="0">
                 <a:solidFill>
-                  <a:srgbClr val="383A42"/>
+                  <a:srgbClr val="4078F2"/>
                 </a:solidFill>
                 <a:effectLst/>
                 <a:latin typeface="Fira Code" panose="020B0809050000020004" pitchFamily="49" charset="0"/>
               </a:rPr>
-              <a:t>(</a:t>
+              <a:t>=</a:t>
             </a:r>
             <a:r>
               <a:rPr lang="en-US" sz="1400" b="0" i="0" dirty="0">
                 <a:solidFill>
-                  <a:srgbClr val="E45649"/>
+                  <a:srgbClr val="383A42"/>
                 </a:solidFill>
                 <a:effectLst/>
                 <a:latin typeface="Fira Code" panose="020B0809050000020004" pitchFamily="49" charset="0"/>
               </a:rPr>
-              <a:t>R</a:t>
-            </a:r>
-            <a:r>
-              <a:rPr lang="en-US" sz="1400" b="0" i="0" dirty="0">
-                <a:solidFill>
-                  <a:srgbClr val="4078F2"/>
+              <a:t> ALU_XOR; </a:t>
+            </a:r>
+            <a:r>
+              <a:rPr lang="en-US" sz="1400" b="0" i="1" dirty="0">
+                <a:solidFill>
+                  <a:srgbClr val="A0A1A7"/>
                 </a:solidFill>
                 <a:effectLst/>
                 <a:latin typeface="Fira Code" panose="020B0809050000020004" pitchFamily="49" charset="0"/>
               </a:rPr>
-              <a:t>-</a:t>
-            </a:r>
-            <a:r>
-              <a:rPr lang="en-US" sz="1400" b="0" i="0" dirty="0">
-                <a:solidFill>
-                  <a:srgbClr val="E45649"/>
-                </a:solidFill>
-                <a:effectLst/>
-                <a:latin typeface="Fira Code" panose="020B0809050000020004" pitchFamily="49" charset="0"/>
-              </a:rPr>
-              <a:t>type or I</a:t>
-            </a:r>
-            <a:r>
-              <a:rPr lang="en-US" sz="1400" b="0" i="0" dirty="0">
-                <a:solidFill>
-                  <a:srgbClr val="4078F2"/>
-                </a:solidFill>
-                <a:effectLst/>
-                <a:latin typeface="Fira Code" panose="020B0809050000020004" pitchFamily="49" charset="0"/>
-              </a:rPr>
-              <a:t>-</a:t>
-            </a:r>
-            <a:r>
-              <a:rPr lang="en-US" sz="1400" b="0" i="0" dirty="0">
-                <a:solidFill>
-                  <a:srgbClr val="E45649"/>
-                </a:solidFill>
-                <a:effectLst/>
-                <a:latin typeface="Fira Code" panose="020B0809050000020004" pitchFamily="49" charset="0"/>
-              </a:rPr>
-              <a:t>type arithmetic</a:t>
-            </a:r>
-            <a:r>
-              <a:rPr lang="en-US" sz="1400" b="0" i="0" dirty="0">
-                <a:solidFill>
-                  <a:srgbClr val="383A42"/>
-                </a:solidFill>
-                <a:effectLst/>
-                <a:latin typeface="Fira Code" panose="020B0809050000020004" pitchFamily="49" charset="0"/>
-              </a:rPr>
-              <a:t>) </a:t>
-            </a:r>
-          </a:p>
-          <a:p>
-            <a:pPr marL="0" indent="0">
-              <a:buNone/>
-            </a:pPr>
-            <a:r>
-              <a:rPr lang="en-US" sz="1400" dirty="0">
-                <a:solidFill>
-                  <a:srgbClr val="383A42"/>
-                </a:solidFill>
-                <a:latin typeface="Fira Code" panose="020B0809050000020004" pitchFamily="49" charset="0"/>
-              </a:rPr>
-              <a:t>	</a:t>
-            </a:r>
-            <a:r>
-              <a:rPr lang="en-US" sz="1400" b="0" i="0" dirty="0" err="1">
-                <a:solidFill>
-                  <a:srgbClr val="383A42"/>
-                </a:solidFill>
-                <a:effectLst/>
-                <a:latin typeface="Fira Code" panose="020B0809050000020004" pitchFamily="49" charset="0"/>
-              </a:rPr>
-              <a:t>alu_op</a:t>
+              <a:t>// XOR / XORI</a:t>
             </a:r>
             <a:r>
               <a:rPr lang="en-US" sz="1400" b="0" i="0" dirty="0">
@@ -25581,15 +24167,100 @@
               </a:rPr>
               <a:t> </a:t>
             </a:r>
+          </a:p>
+          <a:p>
+            <a:pPr marL="0" indent="0">
+              <a:buNone/>
+            </a:pPr>
+            <a:r>
+              <a:rPr lang="en-US" sz="1400" dirty="0">
+                <a:solidFill>
+                  <a:srgbClr val="383A42"/>
+                </a:solidFill>
+                <a:latin typeface="Fira Code" panose="020B0809050000020004" pitchFamily="49" charset="0"/>
+              </a:rPr>
+              <a:t>			   </a:t>
+            </a:r>
             <a:r>
               <a:rPr lang="en-US" sz="1400" b="0" i="0" dirty="0">
                 <a:solidFill>
-                  <a:srgbClr val="4078F2"/>
+                  <a:srgbClr val="B76B01"/>
                 </a:solidFill>
                 <a:effectLst/>
                 <a:latin typeface="Fira Code" panose="020B0809050000020004" pitchFamily="49" charset="0"/>
               </a:rPr>
-              <a:t>==</a:t>
+              <a:t>3'b101</a:t>
+            </a:r>
+            <a:r>
+              <a:rPr lang="en-US" sz="1400" b="0" i="0" dirty="0">
+                <a:solidFill>
+                  <a:srgbClr val="383A42"/>
+                </a:solidFill>
+                <a:effectLst/>
+                <a:latin typeface="Fira Code" panose="020B0809050000020004" pitchFamily="49" charset="0"/>
+              </a:rPr>
+              <a:t>: </a:t>
+            </a:r>
+            <a:r>
+              <a:rPr lang="en-US" sz="1400" b="0" i="0" dirty="0">
+                <a:solidFill>
+                  <a:srgbClr val="A626A4"/>
+                </a:solidFill>
+                <a:effectLst/>
+                <a:latin typeface="Fira Code" panose="020B0809050000020004" pitchFamily="49" charset="0"/>
+              </a:rPr>
+              <a:t>begin</a:t>
+            </a:r>
+            <a:endParaRPr lang="en-US" sz="1400" b="0" i="0" dirty="0">
+              <a:solidFill>
+                <a:srgbClr val="383A42"/>
+              </a:solidFill>
+              <a:effectLst/>
+              <a:latin typeface="Fira Code" panose="020B0809050000020004" pitchFamily="49" charset="0"/>
+            </a:endParaRPr>
+          </a:p>
+          <a:p>
+            <a:pPr marL="0" indent="0">
+              <a:buNone/>
+            </a:pPr>
+            <a:r>
+              <a:rPr lang="en-US" sz="1400" dirty="0">
+                <a:solidFill>
+                  <a:srgbClr val="383A42"/>
+                </a:solidFill>
+                <a:latin typeface="Fira Code" panose="020B0809050000020004" pitchFamily="49" charset="0"/>
+              </a:rPr>
+              <a:t>				</a:t>
+            </a:r>
+            <a:r>
+              <a:rPr lang="en-US" sz="1400" b="0" i="0" dirty="0">
+                <a:solidFill>
+                  <a:srgbClr val="A626A4"/>
+                </a:solidFill>
+                <a:effectLst/>
+                <a:latin typeface="Fira Code" panose="020B0809050000020004" pitchFamily="49" charset="0"/>
+              </a:rPr>
+              <a:t>if</a:t>
+            </a:r>
+            <a:r>
+              <a:rPr lang="en-US" sz="1400" b="0" i="0" dirty="0">
+                <a:solidFill>
+                  <a:srgbClr val="383A42"/>
+                </a:solidFill>
+                <a:effectLst/>
+                <a:latin typeface="Fira Code" panose="020B0809050000020004" pitchFamily="49" charset="0"/>
+              </a:rPr>
+              <a:t> (funct7_bit5) </a:t>
+            </a:r>
+            <a:r>
+              <a:rPr lang="en-US" sz="1400" b="0" i="0" dirty="0" err="1">
+                <a:solidFill>
+                  <a:srgbClr val="383A42"/>
+                </a:solidFill>
+                <a:effectLst/>
+                <a:latin typeface="Fira Code" panose="020B0809050000020004" pitchFamily="49" charset="0"/>
+              </a:rPr>
+              <a:t>alu_control</a:t>
             </a:r>
             <a:r>
               <a:rPr lang="en-US" sz="1400" b="0" i="0" dirty="0">
@@ -25604,12 +24275,12 @@
             <a:r>
               <a:rPr lang="en-US" sz="1400" b="0" i="0" dirty="0">
                 <a:solidFill>
-                  <a:srgbClr val="B76B01"/>
+                  <a:srgbClr val="4078F2"/>
                 </a:solidFill>
                 <a:effectLst/>
                 <a:latin typeface="Fira Code" panose="020B0809050000020004" pitchFamily="49" charset="0"/>
               </a:rPr>
-              <a:t>2</a:t>
+              <a:t>=</a:t>
             </a:r>
             <a:r>
               <a:rPr lang="en-US" sz="1400" b="0" i="0" dirty="0">
@@ -25619,17 +24290,17 @@
                 <a:effectLst/>
                 <a:latin typeface="Fira Code" panose="020B0809050000020004" pitchFamily="49" charset="0"/>
               </a:rPr>
-              <a:t>'b10 </a:t>
+              <a:t> ALU_SRA; </a:t>
             </a:r>
             <a:r>
               <a:rPr lang="en-US" sz="1400" b="0" i="0" dirty="0">
                 <a:solidFill>
-                  <a:srgbClr val="4078F2"/>
+                  <a:srgbClr val="A626A4"/>
                 </a:solidFill>
                 <a:effectLst/>
                 <a:latin typeface="Fira Code" panose="020B0809050000020004" pitchFamily="49" charset="0"/>
               </a:rPr>
-              <a:t>:</a:t>
+              <a:t>else</a:t>
             </a:r>
             <a:r>
               <a:rPr lang="en-US" sz="1400" b="0" i="0" dirty="0">
@@ -25641,39 +24312,15 @@
               </a:rPr>
               <a:t> </a:t>
             </a:r>
-          </a:p>
-          <a:p>
-            <a:pPr marL="0" indent="0">
-              <a:buNone/>
-            </a:pPr>
-            <a:r>
-              <a:rPr lang="en-US" sz="1400" dirty="0">
-                <a:solidFill>
-                  <a:srgbClr val="383A42"/>
-                </a:solidFill>
-                <a:latin typeface="Fira Code" panose="020B0809050000020004" pitchFamily="49" charset="0"/>
-              </a:rPr>
-              <a:t>	</a:t>
-            </a:r>
-            <a:r>
-              <a:rPr lang="en-US" sz="1400" b="0" i="0" dirty="0">
+            <a:r>
+              <a:rPr lang="en-US" sz="1400" b="0" i="0" dirty="0" err="1">
                 <a:solidFill>
                   <a:srgbClr val="383A42"/>
                 </a:solidFill>
                 <a:effectLst/>
                 <a:latin typeface="Fira Code" panose="020B0809050000020004" pitchFamily="49" charset="0"/>
               </a:rPr>
-              <a:t>[ funct3 </a:t>
-            </a:r>
-            <a:r>
-              <a:rPr lang="en-US" sz="1400" b="0" i="0" dirty="0">
-                <a:solidFill>
-                  <a:srgbClr val="4078F2"/>
-                </a:solidFill>
-                <a:effectLst/>
-                <a:latin typeface="Fira Code" panose="020B0809050000020004" pitchFamily="49" charset="0"/>
-              </a:rPr>
-              <a:t>==</a:t>
+              <a:t>alu_control</a:t>
             </a:r>
             <a:r>
               <a:rPr lang="en-US" sz="1400" b="0" i="0" dirty="0">
@@ -25688,12 +24335,12 @@
             <a:r>
               <a:rPr lang="en-US" sz="1400" b="0" i="0" dirty="0">
                 <a:solidFill>
-                  <a:srgbClr val="B76B01"/>
+                  <a:srgbClr val="4078F2"/>
                 </a:solidFill>
                 <a:effectLst/>
                 <a:latin typeface="Fira Code" panose="020B0809050000020004" pitchFamily="49" charset="0"/>
               </a:rPr>
-              <a:t>3</a:t>
+              <a:t>=</a:t>
             </a:r>
             <a:r>
               <a:rPr lang="en-US" sz="1400" b="0" i="0" dirty="0">
@@ -25703,57 +24350,17 @@
                 <a:effectLst/>
                 <a:latin typeface="Fira Code" panose="020B0809050000020004" pitchFamily="49" charset="0"/>
               </a:rPr>
-              <a:t>'b000 </a:t>
+              <a:t> ALU_SRL; </a:t>
             </a:r>
             <a:r>
               <a:rPr lang="en-US" sz="1400" b="0" i="0" dirty="0">
                 <a:solidFill>
-                  <a:srgbClr val="4078F2"/>
+                  <a:srgbClr val="A626A4"/>
                 </a:solidFill>
                 <a:effectLst/>
                 <a:latin typeface="Fira Code" panose="020B0809050000020004" pitchFamily="49" charset="0"/>
               </a:rPr>
-              <a:t>&amp;&amp;</a:t>
-            </a:r>
-            <a:r>
-              <a:rPr lang="en-US" sz="1400" b="0" i="0" dirty="0">
-                <a:solidFill>
-                  <a:srgbClr val="383A42"/>
-                </a:solidFill>
-                <a:effectLst/>
-                <a:latin typeface="Fira Code" panose="020B0809050000020004" pitchFamily="49" charset="0"/>
-              </a:rPr>
-              <a:t> funct7_5 </a:t>
-            </a:r>
-            <a:r>
-              <a:rPr lang="en-US" sz="1400" b="0" i="0" dirty="0">
-                <a:solidFill>
-                  <a:srgbClr val="4078F2"/>
-                </a:solidFill>
-                <a:effectLst/>
-                <a:latin typeface="Fira Code" panose="020B0809050000020004" pitchFamily="49" charset="0"/>
-              </a:rPr>
-              <a:t>:</a:t>
-            </a:r>
-            <a:r>
-              <a:rPr lang="en-US" sz="1400" b="0" i="0" dirty="0">
-                <a:solidFill>
-                  <a:srgbClr val="383A42"/>
-                </a:solidFill>
-                <a:effectLst/>
-                <a:latin typeface="Fira Code" panose="020B0809050000020004" pitchFamily="49" charset="0"/>
-              </a:rPr>
-              <a:t> ALU_SUB; </a:t>
-            </a:r>
-            <a:r>
-              <a:rPr lang="en-US" sz="1400" b="0" i="1" dirty="0">
-                <a:solidFill>
-                  <a:srgbClr val="A0A1A7"/>
-                </a:solidFill>
-                <a:effectLst/>
-                <a:latin typeface="Fira Code" panose="020B0809050000020004" pitchFamily="49" charset="0"/>
-              </a:rPr>
-              <a:t>// SUB</a:t>
+              <a:t>end</a:t>
             </a:r>
             <a:r>
               <a:rPr lang="en-US" sz="1400" b="0" i="0" dirty="0">
@@ -25777,27 +24384,37 @@
                 </a:solidFill>
                 <a:latin typeface="Fira Code" panose="020B0809050000020004" pitchFamily="49" charset="0"/>
               </a:rPr>
-              <a:t>	  </a:t>
+              <a:t>			   </a:t>
             </a:r>
             <a:r>
               <a:rPr lang="en-US" sz="1400" b="0" i="0" dirty="0">
                 <a:solidFill>
-                  <a:srgbClr val="383A42"/>
+                  <a:srgbClr val="B76B01"/>
                 </a:solidFill>
                 <a:effectLst/>
                 <a:latin typeface="Fira Code" panose="020B0809050000020004" pitchFamily="49" charset="0"/>
               </a:rPr>
-              <a:t>funct3 </a:t>
+              <a:t>3'b110</a:t>
             </a:r>
             <a:r>
               <a:rPr lang="en-US" sz="1400" b="0" i="0" dirty="0">
                 <a:solidFill>
-                  <a:srgbClr val="4078F2"/>
+                  <a:srgbClr val="383A42"/>
                 </a:solidFill>
                 <a:effectLst/>
                 <a:latin typeface="Fira Code" panose="020B0809050000020004" pitchFamily="49" charset="0"/>
               </a:rPr>
-              <a:t>==</a:t>
+              <a:t>: </a:t>
+            </a:r>
+            <a:r>
+              <a:rPr lang="en-US" sz="1400" b="0" i="0" dirty="0" err="1">
+                <a:solidFill>
+                  <a:srgbClr val="383A42"/>
+                </a:solidFill>
+                <a:effectLst/>
+                <a:latin typeface="Fira Code" panose="020B0809050000020004" pitchFamily="49" charset="0"/>
+              </a:rPr>
+              <a:t>alu_control</a:t>
             </a:r>
             <a:r>
               <a:rPr lang="en-US" sz="1400" b="0" i="0" dirty="0">
@@ -25812,12 +24429,12 @@
             <a:r>
               <a:rPr lang="en-US" sz="1400" b="0" i="0" dirty="0">
                 <a:solidFill>
-                  <a:srgbClr val="B76B01"/>
+                  <a:srgbClr val="4078F2"/>
                 </a:solidFill>
                 <a:effectLst/>
                 <a:latin typeface="Fira Code" panose="020B0809050000020004" pitchFamily="49" charset="0"/>
               </a:rPr>
-              <a:t>3</a:t>
+              <a:t>=</a:t>
             </a:r>
             <a:r>
               <a:rPr lang="en-US" sz="1400" b="0" i="0" dirty="0">
@@ -25827,17 +24444,185 @@
                 <a:effectLst/>
                 <a:latin typeface="Fira Code" panose="020B0809050000020004" pitchFamily="49" charset="0"/>
               </a:rPr>
-              <a:t>'b000 </a:t>
-            </a:r>
-            <a:r>
-              <a:rPr lang="en-US" sz="1400" b="0" i="0" dirty="0">
-                <a:solidFill>
-                  <a:srgbClr val="4078F2"/>
+              <a:t> ALU_OR; </a:t>
+            </a:r>
+            <a:r>
+              <a:rPr lang="en-US" sz="1400" b="0" i="1" dirty="0">
+                <a:solidFill>
+                  <a:srgbClr val="A0A1A7"/>
                 </a:solidFill>
                 <a:effectLst/>
                 <a:latin typeface="Fira Code" panose="020B0809050000020004" pitchFamily="49" charset="0"/>
               </a:rPr>
-              <a:t>:</a:t>
+              <a:t>// OR / ORI</a:t>
+            </a:r>
+            <a:r>
+              <a:rPr lang="en-US" sz="1400" b="0" i="0" dirty="0">
+                <a:solidFill>
+                  <a:srgbClr val="383A42"/>
+                </a:solidFill>
+                <a:effectLst/>
+                <a:latin typeface="Fira Code" panose="020B0809050000020004" pitchFamily="49" charset="0"/>
+              </a:rPr>
+              <a:t> </a:t>
+            </a:r>
+          </a:p>
+          <a:p>
+            <a:pPr marL="0" indent="0">
+              <a:buNone/>
+            </a:pPr>
+            <a:r>
+              <a:rPr lang="en-US" sz="1400" dirty="0">
+                <a:solidFill>
+                  <a:srgbClr val="383A42"/>
+                </a:solidFill>
+                <a:latin typeface="Fira Code" panose="020B0809050000020004" pitchFamily="49" charset="0"/>
+              </a:rPr>
+              <a:t>			   </a:t>
+            </a:r>
+            <a:r>
+              <a:rPr lang="en-US" sz="1400" b="0" i="0" dirty="0">
+                <a:solidFill>
+                  <a:srgbClr val="B76B01"/>
+                </a:solidFill>
+                <a:effectLst/>
+                <a:latin typeface="Fira Code" panose="020B0809050000020004" pitchFamily="49" charset="0"/>
+              </a:rPr>
+              <a:t>3'b111</a:t>
+            </a:r>
+            <a:r>
+              <a:rPr lang="en-US" sz="1400" b="0" i="0" dirty="0">
+                <a:solidFill>
+                  <a:srgbClr val="383A42"/>
+                </a:solidFill>
+                <a:effectLst/>
+                <a:latin typeface="Fira Code" panose="020B0809050000020004" pitchFamily="49" charset="0"/>
+              </a:rPr>
+              <a:t>: </a:t>
+            </a:r>
+            <a:r>
+              <a:rPr lang="en-US" sz="1400" b="0" i="0" dirty="0" err="1">
+                <a:solidFill>
+                  <a:srgbClr val="383A42"/>
+                </a:solidFill>
+                <a:effectLst/>
+                <a:latin typeface="Fira Code" panose="020B0809050000020004" pitchFamily="49" charset="0"/>
+              </a:rPr>
+              <a:t>alu_control</a:t>
+            </a:r>
+            <a:r>
+              <a:rPr lang="en-US" sz="1400" b="0" i="0" dirty="0">
+                <a:solidFill>
+                  <a:srgbClr val="383A42"/>
+                </a:solidFill>
+                <a:effectLst/>
+                <a:latin typeface="Fira Code" panose="020B0809050000020004" pitchFamily="49" charset="0"/>
+              </a:rPr>
+              <a:t> </a:t>
+            </a:r>
+            <a:r>
+              <a:rPr lang="en-US" sz="1400" b="0" i="0" dirty="0">
+                <a:solidFill>
+                  <a:srgbClr val="4078F2"/>
+                </a:solidFill>
+                <a:effectLst/>
+                <a:latin typeface="Fira Code" panose="020B0809050000020004" pitchFamily="49" charset="0"/>
+              </a:rPr>
+              <a:t>=</a:t>
+            </a:r>
+            <a:r>
+              <a:rPr lang="en-US" sz="1400" b="0" i="0" dirty="0">
+                <a:solidFill>
+                  <a:srgbClr val="383A42"/>
+                </a:solidFill>
+                <a:effectLst/>
+                <a:latin typeface="Fira Code" panose="020B0809050000020004" pitchFamily="49" charset="0"/>
+              </a:rPr>
+              <a:t> ALU_AND; </a:t>
+            </a:r>
+            <a:r>
+              <a:rPr lang="en-US" sz="1400" b="0" i="1" dirty="0">
+                <a:solidFill>
+                  <a:srgbClr val="A0A1A7"/>
+                </a:solidFill>
+                <a:effectLst/>
+                <a:latin typeface="Fira Code" panose="020B0809050000020004" pitchFamily="49" charset="0"/>
+              </a:rPr>
+              <a:t>// AND / ANDI</a:t>
+            </a:r>
+            <a:r>
+              <a:rPr lang="en-US" sz="1400" b="0" i="0" dirty="0">
+                <a:solidFill>
+                  <a:srgbClr val="383A42"/>
+                </a:solidFill>
+                <a:effectLst/>
+                <a:latin typeface="Fira Code" panose="020B0809050000020004" pitchFamily="49" charset="0"/>
+              </a:rPr>
+              <a:t> </a:t>
+            </a:r>
+          </a:p>
+          <a:p>
+            <a:pPr marL="0" indent="0">
+              <a:buNone/>
+            </a:pPr>
+            <a:r>
+              <a:rPr lang="en-US" sz="1400" dirty="0">
+                <a:solidFill>
+                  <a:srgbClr val="383A42"/>
+                </a:solidFill>
+                <a:latin typeface="Fira Code" panose="020B0809050000020004" pitchFamily="49" charset="0"/>
+              </a:rPr>
+              <a:t>		</a:t>
+            </a:r>
+            <a:r>
+              <a:rPr lang="en-US" sz="1400" b="0" i="0" dirty="0">
+                <a:solidFill>
+                  <a:srgbClr val="A626A4"/>
+                </a:solidFill>
+                <a:effectLst/>
+                <a:latin typeface="Fira Code" panose="020B0809050000020004" pitchFamily="49" charset="0"/>
+              </a:rPr>
+              <a:t>default</a:t>
+            </a:r>
+            <a:r>
+              <a:rPr lang="en-US" sz="1400" b="0" i="0" dirty="0">
+                <a:solidFill>
+                  <a:srgbClr val="383A42"/>
+                </a:solidFill>
+                <a:effectLst/>
+                <a:latin typeface="Fira Code" panose="020B0809050000020004" pitchFamily="49" charset="0"/>
+              </a:rPr>
+              <a:t>: </a:t>
+            </a:r>
+            <a:r>
+              <a:rPr lang="en-US" sz="1400" b="0" i="0" dirty="0" err="1">
+                <a:solidFill>
+                  <a:srgbClr val="383A42"/>
+                </a:solidFill>
+                <a:effectLst/>
+                <a:latin typeface="Fira Code" panose="020B0809050000020004" pitchFamily="49" charset="0"/>
+              </a:rPr>
+              <a:t>alu_control</a:t>
+            </a:r>
+            <a:r>
+              <a:rPr lang="en-US" sz="1400" b="0" i="0" dirty="0">
+                <a:solidFill>
+                  <a:srgbClr val="383A42"/>
+                </a:solidFill>
+                <a:effectLst/>
+                <a:latin typeface="Fira Code" panose="020B0809050000020004" pitchFamily="49" charset="0"/>
+              </a:rPr>
+              <a:t> </a:t>
+            </a:r>
+            <a:r>
+              <a:rPr lang="en-US" sz="1400" b="0" i="0" dirty="0">
+                <a:solidFill>
+                  <a:srgbClr val="4078F2"/>
+                </a:solidFill>
+                <a:effectLst/>
+                <a:latin typeface="Fira Code" panose="020B0809050000020004" pitchFamily="49" charset="0"/>
+              </a:rPr>
+              <a:t>=</a:t>
             </a:r>
             <a:r>
               <a:rPr lang="en-US" sz="1400" b="0" i="0" dirty="0">
@@ -25849,15 +24634,29 @@
               </a:rPr>
               <a:t> ALU_ADD; </a:t>
             </a:r>
-            <a:r>
-              <a:rPr lang="en-US" sz="1400" b="0" i="1" dirty="0">
-                <a:solidFill>
-                  <a:srgbClr val="A0A1A7"/>
+          </a:p>
+          <a:p>
+            <a:pPr marL="0" indent="0">
+              <a:buNone/>
+            </a:pPr>
+            <a:r>
+              <a:rPr lang="en-US" sz="1400" dirty="0">
+                <a:solidFill>
+                  <a:srgbClr val="383A42"/>
+                </a:solidFill>
+                <a:latin typeface="Fira Code" panose="020B0809050000020004" pitchFamily="49" charset="0"/>
+              </a:rPr>
+              <a:t>		</a:t>
+            </a:r>
+            <a:r>
+              <a:rPr lang="en-US" sz="1400" b="0" i="0" dirty="0" err="1">
+                <a:solidFill>
+                  <a:srgbClr val="A626A4"/>
                 </a:solidFill>
                 <a:effectLst/>
                 <a:latin typeface="Fira Code" panose="020B0809050000020004" pitchFamily="49" charset="0"/>
               </a:rPr>
-              <a:t>// ADD</a:t>
+              <a:t>endcase</a:t>
             </a:r>
             <a:r>
               <a:rPr lang="en-US" sz="1400" b="0" i="0" dirty="0">
@@ -25881,27 +24680,17 @@
                 </a:solidFill>
                 <a:latin typeface="Fira Code" panose="020B0809050000020004" pitchFamily="49" charset="0"/>
               </a:rPr>
-              <a:t>	  </a:t>
+              <a:t>	        </a:t>
             </a:r>
             <a:r>
               <a:rPr lang="en-US" sz="1400" b="0" i="0" dirty="0">
                 <a:solidFill>
-                  <a:srgbClr val="383A42"/>
+                  <a:srgbClr val="A626A4"/>
                 </a:solidFill>
                 <a:effectLst/>
                 <a:latin typeface="Fira Code" panose="020B0809050000020004" pitchFamily="49" charset="0"/>
               </a:rPr>
-              <a:t>funct3 </a:t>
-            </a:r>
-            <a:r>
-              <a:rPr lang="en-US" sz="1400" b="0" i="0" dirty="0">
-                <a:solidFill>
-                  <a:srgbClr val="4078F2"/>
-                </a:solidFill>
-                <a:effectLst/>
-                <a:latin typeface="Fira Code" panose="020B0809050000020004" pitchFamily="49" charset="0"/>
-              </a:rPr>
-              <a:t>==</a:t>
+              <a:t>end</a:t>
             </a:r>
             <a:r>
               <a:rPr lang="en-US" sz="1400" b="0" i="0" dirty="0">
@@ -25913,15 +24702,29 @@
               </a:rPr>
               <a:t> </a:t>
             </a:r>
+          </a:p>
+          <a:p>
+            <a:pPr marL="0" indent="0">
+              <a:buNone/>
+            </a:pPr>
+            <a:r>
+              <a:rPr lang="en-US" sz="1400" dirty="0">
+                <a:solidFill>
+                  <a:srgbClr val="383A42"/>
+                </a:solidFill>
+                <a:latin typeface="Fira Code" panose="020B0809050000020004" pitchFamily="49" charset="0"/>
+              </a:rPr>
+              <a:t>	</a:t>
+            </a:r>
             <a:r>
               <a:rPr lang="en-US" sz="1400" b="0" i="0" dirty="0">
                 <a:solidFill>
-                  <a:srgbClr val="B76B01"/>
+                  <a:srgbClr val="A626A4"/>
                 </a:solidFill>
                 <a:effectLst/>
                 <a:latin typeface="Fira Code" panose="020B0809050000020004" pitchFamily="49" charset="0"/>
               </a:rPr>
-              <a:t>3</a:t>
+              <a:t>default</a:t>
             </a:r>
             <a:r>
               <a:rPr lang="en-US" sz="1400" b="0" i="0" dirty="0">
@@ -25931,37 +24734,17 @@
                 <a:effectLst/>
                 <a:latin typeface="Fira Code" panose="020B0809050000020004" pitchFamily="49" charset="0"/>
               </a:rPr>
-              <a:t>'b111 </a:t>
-            </a:r>
-            <a:r>
-              <a:rPr lang="en-US" sz="1400" b="0" i="0" dirty="0">
-                <a:solidFill>
-                  <a:srgbClr val="4078F2"/>
+              <a:t>: </a:t>
+            </a:r>
+            <a:r>
+              <a:rPr lang="en-US" sz="1400" b="0" i="0" dirty="0" err="1">
+                <a:solidFill>
+                  <a:srgbClr val="383A42"/>
                 </a:solidFill>
                 <a:effectLst/>
                 <a:latin typeface="Fira Code" panose="020B0809050000020004" pitchFamily="49" charset="0"/>
               </a:rPr>
-              <a:t>:</a:t>
-            </a:r>
-            <a:r>
-              <a:rPr lang="en-US" sz="1400" b="0" i="0" dirty="0">
-                <a:solidFill>
-                  <a:srgbClr val="383A42"/>
-                </a:solidFill>
-                <a:effectLst/>
-                <a:latin typeface="Fira Code" panose="020B0809050000020004" pitchFamily="49" charset="0"/>
-              </a:rPr>
-              <a:t> ALU_AND; </a:t>
-            </a:r>
-            <a:r>
-              <a:rPr lang="en-US" sz="1400" b="0" i="1" dirty="0">
-                <a:solidFill>
-                  <a:srgbClr val="A0A1A7"/>
-                </a:solidFill>
-                <a:effectLst/>
-                <a:latin typeface="Fira Code" panose="020B0809050000020004" pitchFamily="49" charset="0"/>
-              </a:rPr>
-              <a:t>// AND</a:t>
+              <a:t>alu_control</a:t>
             </a:r>
             <a:r>
               <a:rPr lang="en-US" sz="1400" b="0" i="0" dirty="0">
@@ -25973,257 +24756,15 @@
               </a:rPr>
               <a:t> </a:t>
             </a:r>
-          </a:p>
-          <a:p>
-            <a:pPr marL="0" indent="0">
-              <a:buNone/>
-            </a:pPr>
-            <a:r>
-              <a:rPr lang="en-US" sz="1400" dirty="0">
-                <a:solidFill>
-                  <a:srgbClr val="383A42"/>
-                </a:solidFill>
-                <a:latin typeface="Fira Code" panose="020B0809050000020004" pitchFamily="49" charset="0"/>
-              </a:rPr>
-              <a:t>	  </a:t>
-            </a:r>
             <a:r>
               <a:rPr lang="en-US" sz="1400" b="0" i="0" dirty="0">
                 <a:solidFill>
-                  <a:srgbClr val="383A42"/>
+                  <a:srgbClr val="4078F2"/>
                 </a:solidFill>
                 <a:effectLst/>
                 <a:latin typeface="Fira Code" panose="020B0809050000020004" pitchFamily="49" charset="0"/>
               </a:rPr>
-              <a:t>funct3 </a:t>
-            </a:r>
-            <a:r>
-              <a:rPr lang="en-US" sz="1400" b="0" i="0" dirty="0">
-                <a:solidFill>
-                  <a:srgbClr val="4078F2"/>
-                </a:solidFill>
-                <a:effectLst/>
-                <a:latin typeface="Fira Code" panose="020B0809050000020004" pitchFamily="49" charset="0"/>
-              </a:rPr>
-              <a:t>==</a:t>
-            </a:r>
-            <a:r>
-              <a:rPr lang="en-US" sz="1400" b="0" i="0" dirty="0">
-                <a:solidFill>
-                  <a:srgbClr val="383A42"/>
-                </a:solidFill>
-                <a:effectLst/>
-                <a:latin typeface="Fira Code" panose="020B0809050000020004" pitchFamily="49" charset="0"/>
-              </a:rPr>
-              <a:t> </a:t>
-            </a:r>
-            <a:r>
-              <a:rPr lang="en-US" sz="1400" b="0" i="0" dirty="0">
-                <a:solidFill>
-                  <a:srgbClr val="B76B01"/>
-                </a:solidFill>
-                <a:effectLst/>
-                <a:latin typeface="Fira Code" panose="020B0809050000020004" pitchFamily="49" charset="0"/>
-              </a:rPr>
-              <a:t>3</a:t>
-            </a:r>
-            <a:r>
-              <a:rPr lang="en-US" sz="1400" b="0" i="0" dirty="0">
-                <a:solidFill>
-                  <a:srgbClr val="383A42"/>
-                </a:solidFill>
-                <a:effectLst/>
-                <a:latin typeface="Fira Code" panose="020B0809050000020004" pitchFamily="49" charset="0"/>
-              </a:rPr>
-              <a:t>'b110 </a:t>
-            </a:r>
-            <a:r>
-              <a:rPr lang="en-US" sz="1400" b="0" i="0" dirty="0">
-                <a:solidFill>
-                  <a:srgbClr val="4078F2"/>
-                </a:solidFill>
-                <a:effectLst/>
-                <a:latin typeface="Fira Code" panose="020B0809050000020004" pitchFamily="49" charset="0"/>
-              </a:rPr>
-              <a:t>:</a:t>
-            </a:r>
-            <a:r>
-              <a:rPr lang="en-US" sz="1400" b="0" i="0" dirty="0">
-                <a:solidFill>
-                  <a:srgbClr val="383A42"/>
-                </a:solidFill>
-                <a:effectLst/>
-                <a:latin typeface="Fira Code" panose="020B0809050000020004" pitchFamily="49" charset="0"/>
-              </a:rPr>
-              <a:t> ALU_OR; </a:t>
-            </a:r>
-            <a:r>
-              <a:rPr lang="en-US" sz="1400" b="0" i="1" dirty="0">
-                <a:solidFill>
-                  <a:srgbClr val="A0A1A7"/>
-                </a:solidFill>
-                <a:effectLst/>
-                <a:latin typeface="Fira Code" panose="020B0809050000020004" pitchFamily="49" charset="0"/>
-              </a:rPr>
-              <a:t>// OR</a:t>
-            </a:r>
-            <a:r>
-              <a:rPr lang="en-US" sz="1400" b="0" i="0" dirty="0">
-                <a:solidFill>
-                  <a:srgbClr val="383A42"/>
-                </a:solidFill>
-                <a:effectLst/>
-                <a:latin typeface="Fira Code" panose="020B0809050000020004" pitchFamily="49" charset="0"/>
-              </a:rPr>
-              <a:t> </a:t>
-            </a:r>
-          </a:p>
-          <a:p>
-            <a:pPr marL="0" indent="0">
-              <a:buNone/>
-            </a:pPr>
-            <a:r>
-              <a:rPr lang="en-US" sz="1400" dirty="0">
-                <a:solidFill>
-                  <a:srgbClr val="383A42"/>
-                </a:solidFill>
-                <a:latin typeface="Fira Code" panose="020B0809050000020004" pitchFamily="49" charset="0"/>
-              </a:rPr>
-              <a:t>	  </a:t>
-            </a:r>
-            <a:r>
-              <a:rPr lang="en-US" sz="1400" b="0" i="0" dirty="0">
-                <a:solidFill>
-                  <a:srgbClr val="383A42"/>
-                </a:solidFill>
-                <a:effectLst/>
-                <a:latin typeface="Fira Code" panose="020B0809050000020004" pitchFamily="49" charset="0"/>
-              </a:rPr>
-              <a:t>funct3 </a:t>
-            </a:r>
-            <a:r>
-              <a:rPr lang="en-US" sz="1400" b="0" i="0" dirty="0">
-                <a:solidFill>
-                  <a:srgbClr val="4078F2"/>
-                </a:solidFill>
-                <a:effectLst/>
-                <a:latin typeface="Fira Code" panose="020B0809050000020004" pitchFamily="49" charset="0"/>
-              </a:rPr>
-              <a:t>==</a:t>
-            </a:r>
-            <a:r>
-              <a:rPr lang="en-US" sz="1400" b="0" i="0" dirty="0">
-                <a:solidFill>
-                  <a:srgbClr val="383A42"/>
-                </a:solidFill>
-                <a:effectLst/>
-                <a:latin typeface="Fira Code" panose="020B0809050000020004" pitchFamily="49" charset="0"/>
-              </a:rPr>
-              <a:t> </a:t>
-            </a:r>
-            <a:r>
-              <a:rPr lang="en-US" sz="1400" b="0" i="0" dirty="0">
-                <a:solidFill>
-                  <a:srgbClr val="B76B01"/>
-                </a:solidFill>
-                <a:effectLst/>
-                <a:latin typeface="Fira Code" panose="020B0809050000020004" pitchFamily="49" charset="0"/>
-              </a:rPr>
-              <a:t>3</a:t>
-            </a:r>
-            <a:r>
-              <a:rPr lang="en-US" sz="1400" b="0" i="0" dirty="0">
-                <a:solidFill>
-                  <a:srgbClr val="383A42"/>
-                </a:solidFill>
-                <a:effectLst/>
-                <a:latin typeface="Fira Code" panose="020B0809050000020004" pitchFamily="49" charset="0"/>
-              </a:rPr>
-              <a:t>'b010 </a:t>
-            </a:r>
-            <a:r>
-              <a:rPr lang="en-US" sz="1400" b="0" i="0" dirty="0">
-                <a:solidFill>
-                  <a:srgbClr val="4078F2"/>
-                </a:solidFill>
-                <a:effectLst/>
-                <a:latin typeface="Fira Code" panose="020B0809050000020004" pitchFamily="49" charset="0"/>
-              </a:rPr>
-              <a:t>:</a:t>
-            </a:r>
-            <a:r>
-              <a:rPr lang="en-US" sz="1400" b="0" i="0" dirty="0">
-                <a:solidFill>
-                  <a:srgbClr val="383A42"/>
-                </a:solidFill>
-                <a:effectLst/>
-                <a:latin typeface="Fira Code" panose="020B0809050000020004" pitchFamily="49" charset="0"/>
-              </a:rPr>
-              <a:t> ALU_SLT; </a:t>
-            </a:r>
-            <a:r>
-              <a:rPr lang="en-US" sz="1400" b="0" i="1" dirty="0">
-                <a:solidFill>
-                  <a:srgbClr val="A0A1A7"/>
-                </a:solidFill>
-                <a:effectLst/>
-                <a:latin typeface="Fira Code" panose="020B0809050000020004" pitchFamily="49" charset="0"/>
-              </a:rPr>
-              <a:t>// SLT</a:t>
-            </a:r>
-            <a:r>
-              <a:rPr lang="en-US" sz="1400" b="0" i="0" dirty="0">
-                <a:solidFill>
-                  <a:srgbClr val="383A42"/>
-                </a:solidFill>
-                <a:effectLst/>
-                <a:latin typeface="Fira Code" panose="020B0809050000020004" pitchFamily="49" charset="0"/>
-              </a:rPr>
-              <a:t> </a:t>
-            </a:r>
-          </a:p>
-          <a:p>
-            <a:pPr marL="0" indent="0">
-              <a:buNone/>
-            </a:pPr>
-            <a:r>
-              <a:rPr lang="en-US" sz="1400" dirty="0">
-                <a:solidFill>
-                  <a:srgbClr val="383A42"/>
-                </a:solidFill>
-                <a:latin typeface="Fira Code" panose="020B0809050000020004" pitchFamily="49" charset="0"/>
-              </a:rPr>
-              <a:t>	  </a:t>
-            </a:r>
-            <a:r>
-              <a:rPr lang="en-US" sz="1400" b="0" i="0" dirty="0">
-                <a:solidFill>
-                  <a:srgbClr val="B76B01"/>
-                </a:solidFill>
-                <a:effectLst/>
-                <a:latin typeface="Fira Code" panose="020B0809050000020004" pitchFamily="49" charset="0"/>
-              </a:rPr>
-              <a:t>1</a:t>
-            </a:r>
-            <a:r>
-              <a:rPr lang="en-US" sz="1400" b="0" i="0" dirty="0">
-                <a:solidFill>
-                  <a:srgbClr val="383A42"/>
-                </a:solidFill>
-                <a:effectLst/>
-                <a:latin typeface="Fira Code" panose="020B0809050000020004" pitchFamily="49" charset="0"/>
-              </a:rPr>
-              <a:t>     		  </a:t>
-            </a:r>
-            <a:r>
-              <a:rPr lang="en-US" sz="1400" b="0" i="0" dirty="0">
-                <a:solidFill>
-                  <a:srgbClr val="4078F2"/>
-                </a:solidFill>
-                <a:effectLst/>
-                <a:latin typeface="Fira Code" panose="020B0809050000020004" pitchFamily="49" charset="0"/>
-              </a:rPr>
-              <a:t>:</a:t>
+              <a:t>=</a:t>
             </a:r>
             <a:r>
               <a:rPr lang="en-US" sz="1400" b="0" i="0" dirty="0">
@@ -26235,117 +24776,31 @@
               </a:rPr>
               <a:t> ALU_ADD; </a:t>
             </a:r>
-            <a:r>
-              <a:rPr lang="en-US" sz="1400" b="0" i="1" dirty="0">
-                <a:solidFill>
-                  <a:srgbClr val="A0A1A7"/>
+          </a:p>
+          <a:p>
+            <a:pPr marL="0" indent="0">
+              <a:buNone/>
+            </a:pPr>
+            <a:r>
+              <a:rPr lang="en-US" sz="1400" dirty="0">
+                <a:solidFill>
+                  <a:srgbClr val="383A42"/>
+                </a:solidFill>
+                <a:latin typeface="Fira Code" panose="020B0809050000020004" pitchFamily="49" charset="0"/>
+              </a:rPr>
+              <a:t>	</a:t>
+            </a:r>
+            <a:r>
+              <a:rPr lang="en-US" sz="1400" b="0" i="0" dirty="0" err="1">
+                <a:solidFill>
+                  <a:srgbClr val="A626A4"/>
                 </a:solidFill>
                 <a:effectLst/>
                 <a:latin typeface="Fira Code" panose="020B0809050000020004" pitchFamily="49" charset="0"/>
               </a:rPr>
-              <a:t>// Default</a:t>
-            </a:r>
-            <a:r>
-              <a:rPr lang="en-US" sz="1400" b="0" i="0" dirty="0">
-                <a:solidFill>
-                  <a:srgbClr val="383A42"/>
-                </a:solidFill>
-                <a:effectLst/>
-                <a:latin typeface="Fira Code" panose="020B0809050000020004" pitchFamily="49" charset="0"/>
-              </a:rPr>
-              <a:t> ]; </a:t>
-            </a:r>
-          </a:p>
-          <a:p>
-            <a:pPr marL="0" indent="0">
-              <a:buNone/>
-            </a:pPr>
-            <a:r>
-              <a:rPr lang="en-US" sz="1400" b="0" i="0" dirty="0">
-                <a:solidFill>
-                  <a:srgbClr val="E45649"/>
-                </a:solidFill>
-                <a:effectLst/>
-                <a:latin typeface="Fira Code" panose="020B0809050000020004" pitchFamily="49" charset="0"/>
-              </a:rPr>
-              <a:t># Default </a:t>
-            </a:r>
-            <a:r>
-              <a:rPr lang="en-US" sz="1400" b="0" i="0" dirty="0">
-                <a:solidFill>
-                  <a:srgbClr val="A626A4"/>
-                </a:solidFill>
-                <a:effectLst/>
-                <a:latin typeface="Fira Code" panose="020B0809050000020004" pitchFamily="49" charset="0"/>
-              </a:rPr>
-              <a:t>case</a:t>
-            </a:r>
-            <a:r>
-              <a:rPr lang="en-US" sz="1400" b="0" i="0" dirty="0">
-                <a:solidFill>
-                  <a:srgbClr val="383A42"/>
-                </a:solidFill>
-                <a:effectLst/>
-                <a:latin typeface="Fira Code" panose="020B0809050000020004" pitchFamily="49" charset="0"/>
-              </a:rPr>
-              <a:t> </a:t>
-            </a:r>
-            <a:r>
-              <a:rPr lang="en-US" sz="1400" b="0" i="0" dirty="0">
-                <a:solidFill>
-                  <a:srgbClr val="B76B01"/>
-                </a:solidFill>
-                <a:effectLst/>
-                <a:latin typeface="Fira Code" panose="020B0809050000020004" pitchFamily="49" charset="0"/>
-              </a:rPr>
-              <a:t>1</a:t>
-            </a:r>
-            <a:r>
-              <a:rPr lang="en-US" sz="1400" b="0" i="0" dirty="0">
-                <a:solidFill>
-                  <a:srgbClr val="383A42"/>
-                </a:solidFill>
-                <a:effectLst/>
-                <a:latin typeface="Fira Code" panose="020B0809050000020004" pitchFamily="49" charset="0"/>
-              </a:rPr>
-              <a:t> </a:t>
-            </a:r>
-            <a:r>
-              <a:rPr lang="en-US" sz="1400" b="0" i="0" dirty="0">
-                <a:solidFill>
-                  <a:srgbClr val="4078F2"/>
-                </a:solidFill>
-                <a:effectLst/>
-                <a:latin typeface="Fira Code" panose="020B0809050000020004" pitchFamily="49" charset="0"/>
-              </a:rPr>
-              <a:t>:</a:t>
-            </a:r>
-            <a:r>
-              <a:rPr lang="en-US" sz="1400" b="0" i="0" dirty="0">
-                <a:solidFill>
-                  <a:srgbClr val="383A42"/>
-                </a:solidFill>
-                <a:effectLst/>
-                <a:latin typeface="Fira Code" panose="020B0809050000020004" pitchFamily="49" charset="0"/>
-              </a:rPr>
-              <a:t> ALU_ADD; </a:t>
-            </a:r>
-          </a:p>
-          <a:p>
-            <a:pPr marL="0" indent="0">
-              <a:buNone/>
-            </a:pPr>
-            <a:r>
-              <a:rPr lang="en-US" sz="1400" b="0" i="0" dirty="0">
-                <a:solidFill>
-                  <a:srgbClr val="383A42"/>
-                </a:solidFill>
-                <a:effectLst/>
-                <a:latin typeface="Fira Code" panose="020B0809050000020004" pitchFamily="49" charset="0"/>
-              </a:rPr>
-              <a:t>];</a:t>
-            </a:r>
-            <a:endParaRPr lang="en-AU" altLang="zh-TW" sz="3200" dirty="0">
+              <a:t>endcase</a:t>
+            </a:r>
+            <a:endParaRPr lang="en-AU" altLang="zh-TW" sz="1400" dirty="0">
               <a:ea typeface="新細明體" panose="02020500000000000000" pitchFamily="18" charset="-120"/>
             </a:endParaRPr>
           </a:p>
@@ -26505,6 +24960,286 @@
           </a:prstGeom>
         </p:spPr>
       </p:pic>
+      <p:sp>
+        <p:nvSpPr>
+          <p:cNvPr id="2" name="Oval 1">
+            <a:extLst>
+              <a:ext uri="{FF2B5EF4-FFF2-40B4-BE49-F238E27FC236}">
+                <a16:creationId xmlns:a16="http://schemas.microsoft.com/office/drawing/2014/main" id="{D8CEBA0D-6678-4287-8BBF-CB93303E82E0}"/>
+              </a:ext>
+            </a:extLst>
+          </p:cNvPr>
+          <p:cNvSpPr/>
+          <p:nvPr/>
+        </p:nvSpPr>
+        <p:spPr bwMode="auto">
+          <a:xfrm>
+            <a:off x="4410075" y="4048124"/>
+            <a:ext cx="1171575" cy="1381126"/>
+          </a:xfrm>
+          <a:prstGeom prst="ellipse">
+            <a:avLst/>
+          </a:prstGeom>
+          <a:noFill/>
+          <a:ln w="15875" cap="flat" cmpd="sng" algn="ctr">
+            <a:solidFill>
+              <a:srgbClr val="FFFF00"/>
+            </a:solidFill>
+            <a:prstDash val="solid"/>
+            <a:round/>
+            <a:headEnd type="none" w="med" len="med"/>
+            <a:tailEnd type="none" w="med" len="med"/>
+          </a:ln>
+          <a:effectLst/>
+        </p:spPr>
+        <p:txBody>
+          <a:bodyPr vert="horz" wrap="none" lIns="91440" tIns="45720" rIns="91440" bIns="45720" numCol="1" rtlCol="0" anchor="ctr" anchorCtr="0" compatLnSpc="1">
+            <a:prstTxWarp prst="textNoShape">
+              <a:avLst/>
+            </a:prstTxWarp>
+          </a:bodyPr>
+          <a:lstStyle/>
+          <a:p>
+            <a:pPr marL="0" marR="0" indent="0" algn="ctr" defTabSz="914400" rtl="0" eaLnBrk="1" fontAlgn="base" latinLnBrk="0" hangingPunct="1">
+              <a:lnSpc>
+                <a:spcPct val="100000"/>
+              </a:lnSpc>
+              <a:spcBef>
+                <a:spcPct val="0"/>
+              </a:spcBef>
+              <a:spcAft>
+                <a:spcPct val="0"/>
+              </a:spcAft>
+              <a:buClrTx/>
+              <a:buSzTx/>
+              <a:buFontTx/>
+              <a:buNone/>
+              <a:tabLst/>
+            </a:pPr>
+            <a:endParaRPr kumimoji="1" lang="en-US" sz="1800" b="1" i="0" u="none" strike="noStrike" cap="none" normalizeH="0" baseline="0">
+              <a:ln>
+                <a:noFill/>
+              </a:ln>
+              <a:solidFill>
+                <a:schemeClr val="tx1"/>
+              </a:solidFill>
+              <a:effectLst/>
+              <a:latin typeface="Arial" pitchFamily="34" charset="0"/>
+              <a:ea typeface="新細明體" pitchFamily="18" charset="-120"/>
+            </a:endParaRPr>
+          </a:p>
+        </p:txBody>
+      </p:sp>
+      <p:sp>
+        <p:nvSpPr>
+          <p:cNvPr id="8" name="Oval 7">
+            <a:extLst>
+              <a:ext uri="{FF2B5EF4-FFF2-40B4-BE49-F238E27FC236}">
+                <a16:creationId xmlns:a16="http://schemas.microsoft.com/office/drawing/2014/main" id="{C257EDC0-F2A4-4F88-9593-581530CE4AC4}"/>
+              </a:ext>
+            </a:extLst>
+          </p:cNvPr>
+          <p:cNvSpPr/>
+          <p:nvPr/>
+        </p:nvSpPr>
+        <p:spPr bwMode="auto">
+          <a:xfrm>
+            <a:off x="6791325" y="2738437"/>
+            <a:ext cx="1171575" cy="1381126"/>
+          </a:xfrm>
+          <a:prstGeom prst="ellipse">
+            <a:avLst/>
+          </a:prstGeom>
+          <a:noFill/>
+          <a:ln w="15875" cap="flat" cmpd="sng" algn="ctr">
+            <a:solidFill>
+              <a:srgbClr val="FFFF00"/>
+            </a:solidFill>
+            <a:prstDash val="solid"/>
+            <a:round/>
+            <a:headEnd type="none" w="med" len="med"/>
+            <a:tailEnd type="none" w="med" len="med"/>
+          </a:ln>
+          <a:effectLst/>
+        </p:spPr>
+        <p:txBody>
+          <a:bodyPr vert="horz" wrap="none" lIns="91440" tIns="45720" rIns="91440" bIns="45720" numCol="1" rtlCol="0" anchor="ctr" anchorCtr="0" compatLnSpc="1">
+            <a:prstTxWarp prst="textNoShape">
+              <a:avLst/>
+            </a:prstTxWarp>
+          </a:bodyPr>
+          <a:lstStyle/>
+          <a:p>
+            <a:pPr marL="0" marR="0" indent="0" algn="ctr" defTabSz="914400" rtl="0" eaLnBrk="1" fontAlgn="base" latinLnBrk="0" hangingPunct="1">
+              <a:lnSpc>
+                <a:spcPct val="100000"/>
+              </a:lnSpc>
+              <a:spcBef>
+                <a:spcPct val="0"/>
+              </a:spcBef>
+              <a:spcAft>
+                <a:spcPct val="0"/>
+              </a:spcAft>
+              <a:buClrTx/>
+              <a:buSzTx/>
+              <a:buFontTx/>
+              <a:buNone/>
+              <a:tabLst/>
+            </a:pPr>
+            <a:endParaRPr kumimoji="1" lang="en-US" sz="1800" b="1" i="0" u="none" strike="noStrike" cap="none" normalizeH="0" baseline="0">
+              <a:ln>
+                <a:noFill/>
+              </a:ln>
+              <a:solidFill>
+                <a:schemeClr val="tx1"/>
+              </a:solidFill>
+              <a:effectLst/>
+              <a:latin typeface="Arial" pitchFamily="34" charset="0"/>
+              <a:ea typeface="新細明體" pitchFamily="18" charset="-120"/>
+            </a:endParaRPr>
+          </a:p>
+        </p:txBody>
+      </p:sp>
+      <p:sp>
+        <p:nvSpPr>
+          <p:cNvPr id="9" name="Oval 8">
+            <a:extLst>
+              <a:ext uri="{FF2B5EF4-FFF2-40B4-BE49-F238E27FC236}">
+                <a16:creationId xmlns:a16="http://schemas.microsoft.com/office/drawing/2014/main" id="{67C33710-76E4-4D8C-AACE-1B1E87E73388}"/>
+              </a:ext>
+            </a:extLst>
+          </p:cNvPr>
+          <p:cNvSpPr/>
+          <p:nvPr/>
+        </p:nvSpPr>
+        <p:spPr bwMode="auto">
+          <a:xfrm>
+            <a:off x="8005762" y="2505074"/>
+            <a:ext cx="1171575" cy="2009775"/>
+          </a:xfrm>
+          <a:prstGeom prst="ellipse">
+            <a:avLst/>
+          </a:prstGeom>
+          <a:noFill/>
+          <a:ln w="15875" cap="flat" cmpd="sng" algn="ctr">
+            <a:solidFill>
+              <a:srgbClr val="FFFF00"/>
+            </a:solidFill>
+            <a:prstDash val="solid"/>
+            <a:round/>
+            <a:headEnd type="none" w="med" len="med"/>
+            <a:tailEnd type="none" w="med" len="med"/>
+          </a:ln>
+          <a:effectLst/>
+        </p:spPr>
+        <p:txBody>
+          <a:bodyPr vert="horz" wrap="none" lIns="91440" tIns="45720" rIns="91440" bIns="45720" numCol="1" rtlCol="0" anchor="ctr" anchorCtr="0" compatLnSpc="1">
+            <a:prstTxWarp prst="textNoShape">
+              <a:avLst/>
+            </a:prstTxWarp>
+          </a:bodyPr>
+          <a:lstStyle/>
+          <a:p>
+            <a:pPr marL="0" marR="0" indent="0" algn="ctr" defTabSz="914400" rtl="0" eaLnBrk="1" fontAlgn="base" latinLnBrk="0" hangingPunct="1">
+              <a:lnSpc>
+                <a:spcPct val="100000"/>
+              </a:lnSpc>
+              <a:spcBef>
+                <a:spcPct val="0"/>
+              </a:spcBef>
+              <a:spcAft>
+                <a:spcPct val="0"/>
+              </a:spcAft>
+              <a:buClrTx/>
+              <a:buSzTx/>
+              <a:buFontTx/>
+              <a:buNone/>
+              <a:tabLst/>
+            </a:pPr>
+            <a:endParaRPr kumimoji="1" lang="en-US" sz="1800" b="1" i="0" u="none" strike="noStrike" cap="none" normalizeH="0" baseline="0">
+              <a:ln>
+                <a:noFill/>
+              </a:ln>
+              <a:solidFill>
+                <a:schemeClr val="tx1"/>
+              </a:solidFill>
+              <a:effectLst/>
+              <a:latin typeface="Arial" pitchFamily="34" charset="0"/>
+              <a:ea typeface="新細明體" pitchFamily="18" charset="-120"/>
+            </a:endParaRPr>
+          </a:p>
+        </p:txBody>
+      </p:sp>
+      <p:sp>
+        <p:nvSpPr>
+          <p:cNvPr id="10" name="Oval 9">
+            <a:extLst>
+              <a:ext uri="{FF2B5EF4-FFF2-40B4-BE49-F238E27FC236}">
+                <a16:creationId xmlns:a16="http://schemas.microsoft.com/office/drawing/2014/main" id="{7F875BDB-18EC-409A-84C3-F282CA23A8D1}"/>
+              </a:ext>
+            </a:extLst>
+          </p:cNvPr>
+          <p:cNvSpPr/>
+          <p:nvPr/>
+        </p:nvSpPr>
+        <p:spPr bwMode="auto">
+          <a:xfrm>
+            <a:off x="6894111" y="4991100"/>
+            <a:ext cx="1171575" cy="1143000"/>
+          </a:xfrm>
+          <a:prstGeom prst="ellipse">
+            <a:avLst/>
+          </a:prstGeom>
+          <a:noFill/>
+          <a:ln w="15875" cap="flat" cmpd="sng" algn="ctr">
+            <a:solidFill>
+              <a:srgbClr val="FFFF00"/>
+            </a:solidFill>
+            <a:prstDash val="solid"/>
+            <a:round/>
+            <a:headEnd type="none" w="med" len="med"/>
+            <a:tailEnd type="none" w="med" len="med"/>
+          </a:ln>
+          <a:effectLst/>
+        </p:spPr>
+        <p:txBody>
+          <a:bodyPr vert="horz" wrap="none" lIns="91440" tIns="45720" rIns="91440" bIns="45720" numCol="1" rtlCol="0" anchor="ctr" anchorCtr="0" compatLnSpc="1">
+            <a:prstTxWarp prst="textNoShape">
+              <a:avLst/>
+            </a:prstTxWarp>
+          </a:bodyPr>
+          <a:lstStyle/>
+          <a:p>
+            <a:pPr marL="0" marR="0" indent="0" algn="ctr" defTabSz="914400" rtl="0" eaLnBrk="1" fontAlgn="base" latinLnBrk="0" hangingPunct="1">
+              <a:lnSpc>
+                <a:spcPct val="100000"/>
+              </a:lnSpc>
+              <a:spcBef>
+                <a:spcPct val="0"/>
+              </a:spcBef>
+              <a:spcAft>
+                <a:spcPct val="0"/>
+              </a:spcAft>
+              <a:buClrTx/>
+              <a:buSzTx/>
+              <a:buFontTx/>
+              <a:buNone/>
+              <a:tabLst/>
+            </a:pPr>
+            <a:endParaRPr kumimoji="1" lang="en-US" sz="1800" b="1" i="0" u="none" strike="noStrike" cap="none" normalizeH="0" baseline="0">
+              <a:ln>
+                <a:noFill/>
+              </a:ln>
+              <a:solidFill>
+                <a:schemeClr val="tx1"/>
+              </a:solidFill>
+              <a:effectLst/>
+              <a:latin typeface="Arial" pitchFamily="34" charset="0"/>
+              <a:ea typeface="新細明體" pitchFamily="18" charset="-120"/>
+            </a:endParaRPr>
+          </a:p>
+        </p:txBody>
+      </p:sp>
     </p:spTree>
     <p:extLst>
       <p:ext uri="{BB962C8B-B14F-4D97-AF65-F5344CB8AC3E}">
@@ -26515,6 +25250,222 @@
   <p:clrMapOvr>
     <a:masterClrMapping/>
   </p:clrMapOvr>
+  <p:timing>
+    <p:tnLst>
+      <p:par>
+        <p:cTn id="1" dur="indefinite" restart="never" nodeType="tmRoot">
+          <p:childTnLst>
+            <p:seq concurrent="1" nextAc="seek">
+              <p:cTn id="2" dur="indefinite" nodeType="mainSeq">
+                <p:childTnLst>
+                  <p:par>
+                    <p:cTn id="3" fill="hold">
+                      <p:stCondLst>
+                        <p:cond delay="indefinite"/>
+                      </p:stCondLst>
+                      <p:childTnLst>
+                        <p:par>
+                          <p:cTn id="4" fill="hold">
+                            <p:stCondLst>
+                              <p:cond delay="0"/>
+                            </p:stCondLst>
+                            <p:childTnLst>
+                              <p:par>
+                                <p:cTn id="5" presetID="1" presetClass="entr" presetSubtype="0" fill="hold" grpId="0" nodeType="clickEffect">
+                                  <p:stCondLst>
+                                    <p:cond delay="0"/>
+                                  </p:stCondLst>
+                                  <p:childTnLst>
+                                    <p:set>
+                                      <p:cBhvr>
+                                        <p:cTn id="6" dur="1" fill="hold">
+                                          <p:stCondLst>
+                                            <p:cond delay="0"/>
+                                          </p:stCondLst>
+                                        </p:cTn>
+                                        <p:tgtEl>
+                                          <p:spTgt spid="2"/>
+                                        </p:tgtEl>
+                                        <p:attrNameLst>
+                                          <p:attrName>style.visibility</p:attrName>
+                                        </p:attrNameLst>
+                                      </p:cBhvr>
+                                      <p:to>
+                                        <p:strVal val="visible"/>
+                                      </p:to>
+                                    </p:set>
+                                  </p:childTnLst>
+                                </p:cTn>
+                              </p:par>
+                            </p:childTnLst>
+                          </p:cTn>
+                        </p:par>
+                      </p:childTnLst>
+                    </p:cTn>
+                  </p:par>
+                  <p:par>
+                    <p:cTn id="7" fill="hold">
+                      <p:stCondLst>
+                        <p:cond delay="indefinite"/>
+                      </p:stCondLst>
+                      <p:childTnLst>
+                        <p:par>
+                          <p:cTn id="8" fill="hold">
+                            <p:stCondLst>
+                              <p:cond delay="0"/>
+                            </p:stCondLst>
+                            <p:childTnLst>
+                              <p:par>
+                                <p:cTn id="9" presetID="1" presetClass="entr" presetSubtype="0" fill="hold" grpId="0" nodeType="clickEffect">
+                                  <p:stCondLst>
+                                    <p:cond delay="0"/>
+                                  </p:stCondLst>
+                                  <p:childTnLst>
+                                    <p:set>
+                                      <p:cBhvr>
+                                        <p:cTn id="10" dur="1" fill="hold">
+                                          <p:stCondLst>
+                                            <p:cond delay="0"/>
+                                          </p:stCondLst>
+                                        </p:cTn>
+                                        <p:tgtEl>
+                                          <p:spTgt spid="8"/>
+                                        </p:tgtEl>
+                                        <p:attrNameLst>
+                                          <p:attrName>style.visibility</p:attrName>
+                                        </p:attrNameLst>
+                                      </p:cBhvr>
+                                      <p:to>
+                                        <p:strVal val="visible"/>
+                                      </p:to>
+                                    </p:set>
+                                  </p:childTnLst>
+                                </p:cTn>
+                              </p:par>
+                            </p:childTnLst>
+                          </p:cTn>
+                        </p:par>
+                      </p:childTnLst>
+                    </p:cTn>
+                  </p:par>
+                  <p:par>
+                    <p:cTn id="11" fill="hold">
+                      <p:stCondLst>
+                        <p:cond delay="indefinite"/>
+                      </p:stCondLst>
+                      <p:childTnLst>
+                        <p:par>
+                          <p:cTn id="12" fill="hold">
+                            <p:stCondLst>
+                              <p:cond delay="0"/>
+                            </p:stCondLst>
+                            <p:childTnLst>
+                              <p:par>
+                                <p:cTn id="13" presetID="1" presetClass="entr" presetSubtype="0" fill="hold" grpId="0" nodeType="clickEffect">
+                                  <p:stCondLst>
+                                    <p:cond delay="0"/>
+                                  </p:stCondLst>
+                                  <p:childTnLst>
+                                    <p:set>
+                                      <p:cBhvr>
+                                        <p:cTn id="14" dur="1" fill="hold">
+                                          <p:stCondLst>
+                                            <p:cond delay="0"/>
+                                          </p:stCondLst>
+                                        </p:cTn>
+                                        <p:tgtEl>
+                                          <p:spTgt spid="9"/>
+                                        </p:tgtEl>
+                                        <p:attrNameLst>
+                                          <p:attrName>style.visibility</p:attrName>
+                                        </p:attrNameLst>
+                                      </p:cBhvr>
+                                      <p:to>
+                                        <p:strVal val="visible"/>
+                                      </p:to>
+                                    </p:set>
+                                  </p:childTnLst>
+                                </p:cTn>
+                              </p:par>
+                            </p:childTnLst>
+                          </p:cTn>
+                        </p:par>
+                      </p:childTnLst>
+                    </p:cTn>
+                  </p:par>
+                  <p:par>
+                    <p:cTn id="15" fill="hold">
+                      <p:stCondLst>
+                        <p:cond delay="indefinite"/>
+                      </p:stCondLst>
+                      <p:childTnLst>
+                        <p:par>
+                          <p:cTn id="16" fill="hold">
+                            <p:stCondLst>
+                              <p:cond delay="0"/>
+                            </p:stCondLst>
+                            <p:childTnLst>
+                              <p:par>
+                                <p:cTn id="17" presetID="1" presetClass="entr" presetSubtype="0" fill="hold" grpId="0" nodeType="clickEffect">
+                                  <p:stCondLst>
+                                    <p:cond delay="0"/>
+                                  </p:stCondLst>
+                                  <p:childTnLst>
+                                    <p:set>
+                                      <p:cBhvr>
+                                        <p:cTn id="18" dur="1" fill="hold">
+                                          <p:stCondLst>
+                                            <p:cond delay="0"/>
+                                          </p:stCondLst>
+                                        </p:cTn>
+                                        <p:tgtEl>
+                                          <p:spTgt spid="10"/>
+                                        </p:tgtEl>
+                                        <p:attrNameLst>
+                                          <p:attrName>style.visibility</p:attrName>
+                                        </p:attrNameLst>
+                                      </p:cBhvr>
+                                      <p:to>
+                                        <p:strVal val="visible"/>
+                                      </p:to>
+                                    </p:set>
+                                  </p:childTnLst>
+                                </p:cTn>
+                              </p:par>
+                            </p:childTnLst>
+                          </p:cTn>
+                        </p:par>
+                      </p:childTnLst>
+                    </p:cTn>
+                  </p:par>
+                </p:childTnLst>
+              </p:cTn>
+              <p:prevCondLst>
+                <p:cond evt="onPrev" delay="0">
+                  <p:tgtEl>
+                    <p:sldTgt/>
+                  </p:tgtEl>
+                </p:cond>
+              </p:prevCondLst>
+              <p:nextCondLst>
+                <p:cond evt="onNext" delay="0">
+                  <p:tgtEl>
+                    <p:sldTgt/>
+                  </p:tgtEl>
+                </p:cond>
+              </p:nextCondLst>
+            </p:seq>
+          </p:childTnLst>
+        </p:cTn>
+      </p:par>
+    </p:tnLst>
+    <p:bldLst>
+      <p:bldP spid="2" grpId="0" animBg="1"/>
+      <p:bldP spid="8" grpId="0" animBg="1"/>
+      <p:bldP spid="9" grpId="0" animBg="1"/>
+      <p:bldP spid="10" grpId="0" animBg="1"/>
+    </p:bldLst>
+  </p:timing>
 </p:sld>
 </file>
 

</xml_diff>